<commit_message>
Erklärvideo 02 (Online-IDE): Endstand
Co-Authored-By: Claude Opus 5.5 <noreply@anthropic.com>
Claude-Session: https://claude.ai/code/session_01CemoEYGRdCe5FszEBVFFUP
</commit_message>
<xml_diff>
--- a/materialien/Videos/02_Online-IDE_und_Testrunner/AQ_Video02_Online-IDE_und_Testrunner_Folien.pptx
+++ b/materialien/Videos/02_Online-IDE_und_Testrunner/AQ_Video02_Online-IDE_und_Testrunner_Folien.pptx
@@ -5487,7 +5487,7 @@
         <p:spPr>
           <a:xfrm>
             <a:off x="548640" y="1417320"/>
-            <a:ext cx="6050280" cy="1569720"/>
+            <a:ext cx="7772400" cy="1904999"/>
           </a:xfrm>
           <a:prstGeom prst="rect">
             <a:avLst/>
@@ -5533,7 +5533,7 @@
         <p:spPr>
           <a:xfrm>
             <a:off x="640080" y="1490472"/>
-            <a:ext cx="5867399" cy="1478280"/>
+            <a:ext cx="7589520" cy="1813559"/>
           </a:xfrm>
           <a:prstGeom prst="rect">
             <a:avLst/>
@@ -5552,7 +5552,7 @@
               </a:lnSpc>
             </a:pPr>
             <a:r>
-              <a:rPr sz="1600" b="0" i="0">
+              <a:rPr sz="2000" b="0" i="0">
                 <a:solidFill>
                   <a:srgbClr val="A0A7B1"/>
                 </a:solidFill>
@@ -5561,7 +5561,7 @@
               <a:t>1  </a:t>
             </a:r>
             <a:r>
-              <a:rPr sz="1600" b="0" i="0">
+              <a:rPr sz="2000" b="0" i="0">
                 <a:solidFill>
                   <a:srgbClr val="1F2A37"/>
                 </a:solidFill>
@@ -5577,7 +5577,7 @@
               </a:lnSpc>
             </a:pPr>
             <a:r>
-              <a:rPr sz="1600" b="0" i="0">
+              <a:rPr sz="2000" b="0" i="0">
                 <a:solidFill>
                   <a:srgbClr val="A0A7B1"/>
                 </a:solidFill>
@@ -5586,7 +5586,7 @@
               <a:t>2  </a:t>
             </a:r>
             <a:r>
-              <a:rPr sz="1600" b="0" i="0">
+              <a:rPr sz="2000" b="0" i="0">
                 <a:solidFill>
                   <a:srgbClr val="1F2A37"/>
                 </a:solidFill>
@@ -5602,7 +5602,7 @@
               </a:lnSpc>
             </a:pPr>
             <a:r>
-              <a:rPr sz="1600" b="0" i="0">
+              <a:rPr sz="2000" b="0" i="0">
                 <a:solidFill>
                   <a:srgbClr val="A0A7B1"/>
                 </a:solidFill>
@@ -5611,7 +5611,7 @@
               <a:t>3  </a:t>
             </a:r>
             <a:r>
-              <a:rPr sz="1600" b="0" i="0">
+              <a:rPr sz="2000" b="0" i="0">
                 <a:solidFill>
                   <a:srgbClr val="1F2A37"/>
                 </a:solidFill>
@@ -5627,7 +5627,7 @@
               </a:lnSpc>
             </a:pPr>
             <a:r>
-              <a:rPr sz="1600" b="0" i="0">
+              <a:rPr sz="2000" b="0" i="0">
                 <a:solidFill>
                   <a:srgbClr val="A0A7B1"/>
                 </a:solidFill>
@@ -5636,7 +5636,7 @@
               <a:t>4  </a:t>
             </a:r>
             <a:r>
-              <a:rPr sz="1600" b="0" i="0">
+              <a:rPr sz="2000" b="0" i="0">
                 <a:solidFill>
                   <a:srgbClr val="1F2A37"/>
                 </a:solidFill>
@@ -5652,7 +5652,7 @@
               </a:lnSpc>
             </a:pPr>
             <a:r>
-              <a:rPr sz="1600" b="0" i="0">
+              <a:rPr sz="2000" b="0" i="0">
                 <a:solidFill>
                   <a:srgbClr val="A0A7B1"/>
                 </a:solidFill>
@@ -5661,7 +5661,7 @@
               <a:t>5  </a:t>
             </a:r>
             <a:r>
-              <a:rPr sz="1600" b="0" i="0">
+              <a:rPr sz="2000" b="0" i="0">
                 <a:solidFill>
                   <a:srgbClr val="1F2A37"/>
                 </a:solidFill>
@@ -5680,8 +5680,8 @@
         </p:nvSpPr>
         <p:spPr>
           <a:xfrm>
-            <a:off x="548640" y="3124200"/>
-            <a:ext cx="6050280" cy="3230880"/>
+            <a:off x="548640" y="3459480"/>
+            <a:ext cx="7772400" cy="2895600"/>
           </a:xfrm>
           <a:prstGeom prst="rect">
             <a:avLst/>
@@ -5700,7 +5700,7 @@
               </a:spcAft>
             </a:pPr>
             <a:r>
-              <a:rPr sz="2000" b="1" i="0">
+              <a:rPr sz="2200" b="1" i="0">
                 <a:solidFill>
                   <a:srgbClr val="B8860B"/>
                 </a:solidFill>
@@ -5709,7 +5709,7 @@
               <a:t>▸ </a:t>
             </a:r>
             <a:r>
-              <a:rPr sz="2000" b="0" i="0">
+              <a:rPr sz="2200" b="0" i="0">
                 <a:solidFill>
                   <a:srgbClr val="1F2A37"/>
                 </a:solidFill>
@@ -5718,7 +5718,7 @@
               <a:t>Erster Versuch: </a:t>
             </a:r>
             <a:r>
-              <a:rPr sz="1900" b="0" i="0">
+              <a:rPr sz="2100" b="0" i="0">
                 <a:solidFill>
                   <a:srgbClr val="1F4E79"/>
                 </a:solidFill>
@@ -5727,7 +5727,7 @@
               <a:t>10 / 3</a:t>
             </a:r>
             <a:r>
-              <a:rPr sz="2000" b="0" i="0">
+              <a:rPr sz="2200" b="0" i="0">
                 <a:solidFill>
                   <a:srgbClr val="1F2A37"/>
                 </a:solidFill>
@@ -5736,7 +5736,7 @@
               <a:t> = </a:t>
             </a:r>
             <a:r>
-              <a:rPr sz="2000" b="1" i="0">
+              <a:rPr sz="2200" b="1" i="0">
                 <a:solidFill>
                   <a:srgbClr val="1F2A37"/>
                 </a:solidFill>
@@ -5745,7 +5745,7 @@
               <a:t>3</a:t>
             </a:r>
             <a:r>
-              <a:rPr sz="2000" b="0" i="0">
+              <a:rPr sz="2200" b="0" i="0">
                 <a:solidFill>
                   <a:srgbClr val="1F2A37"/>
                 </a:solidFill>
@@ -5754,7 +5754,7 @@
               <a:t> → Test rot</a:t>
             </a:r>
             <a:r>
-              <a:rPr sz="2000" b="0" i="0">
+              <a:rPr sz="2200" b="0" i="0">
                 <a:solidFill>
                   <a:srgbClr val="1F2A37"/>
                 </a:solidFill>
@@ -5770,7 +5770,7 @@
               </a:spcAft>
             </a:pPr>
             <a:r>
-              <a:rPr sz="2000" b="1" i="0">
+              <a:rPr sz="2200" b="1" i="0">
                 <a:solidFill>
                   <a:srgbClr val="B8860B"/>
                 </a:solidFill>
@@ -5779,7 +5779,7 @@
               <a:t>▸ </a:t>
             </a:r>
             <a:r>
-              <a:rPr sz="2000" b="0" i="0">
+              <a:rPr sz="2200" b="0" i="0">
                 <a:solidFill>
                   <a:srgbClr val="1F2A37"/>
                 </a:solidFill>
@@ -5788,7 +5788,7 @@
               <a:t>Korrigiert: </a:t>
             </a:r>
             <a:r>
-              <a:rPr sz="1900" b="0" i="0">
+              <a:rPr sz="2100" b="0" i="0">
                 <a:solidFill>
                   <a:srgbClr val="1F4E79"/>
                 </a:solidFill>
@@ -5797,7 +5797,7 @@
               <a:t>(10 + 2) / 3</a:t>
             </a:r>
             <a:r>
-              <a:rPr sz="2000" b="0" i="0">
+              <a:rPr sz="2200" b="0" i="0">
                 <a:solidFill>
                   <a:srgbClr val="1F2A37"/>
                 </a:solidFill>
@@ -5806,7 +5806,7 @@
               <a:t> = </a:t>
             </a:r>
             <a:r>
-              <a:rPr sz="2000" b="1" i="0">
+              <a:rPr sz="2200" b="1" i="0">
                 <a:solidFill>
                   <a:srgbClr val="1F2A37"/>
                 </a:solidFill>
@@ -5815,7 +5815,7 @@
               <a:t>4</a:t>
             </a:r>
             <a:r>
-              <a:rPr sz="2000" b="0" i="0">
+              <a:rPr sz="2200" b="0" i="0">
                 <a:solidFill>
                   <a:srgbClr val="1F2A37"/>
                 </a:solidFill>
@@ -5824,7 +5824,7 @@
               <a:t> → Test grün</a:t>
             </a:r>
             <a:r>
-              <a:rPr sz="2000" b="0" i="0">
+              <a:rPr sz="2200" b="0" i="0">
                 <a:solidFill>
                   <a:srgbClr val="1F2A37"/>
                 </a:solidFill>
@@ -5833,94 +5833,50 @@
               <a:t/>
             </a:r>
           </a:p>
-        </p:txBody>
-      </p:sp>
-      <p:sp>
-        <p:nvSpPr>
-          <p:cNvPr id="8" name="Rounded Rectangle 7"/>
-          <p:cNvSpPr/>
-          <p:nvPr/>
-        </p:nvSpPr>
-        <p:spPr>
-          <a:xfrm>
-            <a:off x="6873239" y="1325880"/>
-            <a:ext cx="4769815" cy="2651759"/>
-          </a:xfrm>
-          <a:prstGeom prst="roundRect">
-            <a:avLst>
-              <a:gd name="adj" fmla="val 8000"/>
-            </a:avLst>
-          </a:prstGeom>
-          <a:solidFill>
-            <a:srgbClr val="E2EFDA"/>
-          </a:solidFill>
-          <a:ln w="19050">
-            <a:solidFill>
-              <a:srgbClr val="548235"/>
-            </a:solidFill>
-          </a:ln>
-          <a:effectLst/>
-        </p:spPr>
-        <p:style>
-          <a:lnRef idx="1">
-            <a:schemeClr val="accent1"/>
-          </a:lnRef>
-          <a:fillRef idx="3">
-            <a:schemeClr val="accent1"/>
-          </a:fillRef>
-          <a:effectRef idx="2">
-            <a:schemeClr val="accent1"/>
-          </a:effectRef>
-          <a:fontRef idx="minor">
-            <a:schemeClr val="lt1"/>
-          </a:fontRef>
-        </p:style>
-        <p:txBody>
-          <a:bodyPr rtlCol="0" anchor="ctr"/>
-          <a:lstStyle/>
-          <a:p>
-            <a:pPr algn="ctr"/>
-          </a:p>
-        </p:txBody>
-      </p:sp>
-      <p:sp>
-        <p:nvSpPr>
-          <p:cNvPr id="9" name="TextBox 8"/>
-          <p:cNvSpPr txBox="1"/>
-          <p:nvPr/>
-        </p:nvSpPr>
-        <p:spPr>
-          <a:xfrm>
-            <a:off x="7056119" y="1463039"/>
-            <a:ext cx="4404055" cy="2377439"/>
-          </a:xfrm>
-          <a:prstGeom prst="rect">
-            <a:avLst/>
-          </a:prstGeom>
-          <a:noFill/>
-        </p:spPr>
-        <p:txBody>
-          <a:bodyPr wrap="square" anchor="t" lIns="45720" rIns="45720">
-            <a:spAutoFit/>
-          </a:bodyPr>
-          <a:lstStyle/>
           <a:p>
             <a:pPr>
               <a:spcAft>
-                <a:spcPts val="800"/>
+                <a:spcPts val="1000"/>
               </a:spcAft>
             </a:pPr>
             <a:r>
               <a:rPr sz="2200" b="1" i="0">
                 <a:solidFill>
-                  <a:srgbClr val="548235"/>
-                </a:solidFill>
-                <a:latin typeface="Calibri"/>
-              </a:rPr>
-              <a:t>Gute Tests</a:t>
-            </a:r>
-            <a:r>
-              <a:rPr sz="2000" b="0" i="0">
+                  <a:srgbClr val="B8860B"/>
+                </a:solidFill>
+                <a:latin typeface="Calibri"/>
+              </a:rPr>
+              <a:t>▸ </a:t>
+            </a:r>
+            <a:r>
+              <a:rPr sz="2200" b="0" i="0">
+                <a:solidFill>
+                  <a:srgbClr val="1F2A37"/>
+                </a:solidFill>
+                <a:latin typeface="Calibri"/>
+              </a:rPr>
+              <a:t>Gute Tests prüfen </a:t>
+            </a:r>
+            <a:r>
+              <a:rPr sz="2200" b="1" i="0">
+                <a:solidFill>
+                  <a:srgbClr val="1F2A37"/>
+                </a:solidFill>
+                <a:latin typeface="Calibri"/>
+              </a:rPr>
+              <a:t>Grenzfälle</a:t>
+            </a:r>
+            <a:r>
+              <a:rPr sz="2200" b="0" i="0">
+                <a:solidFill>
+                  <a:srgbClr val="1F2A37"/>
+                </a:solidFill>
+                <a:latin typeface="Calibri"/>
+              </a:rPr>
+              <a:t>: 0, genau voll, angebrochen</a:t>
+            </a:r>
+            <a:r>
+              <a:rPr sz="2200" b="0" i="0">
                 <a:solidFill>
                   <a:srgbClr val="1F2A37"/>
                 </a:solidFill>
@@ -5929,54 +5885,11 @@
               <a:t/>
             </a:r>
           </a:p>
-          <a:p>
-            <a:pPr>
-              <a:spcAft>
-                <a:spcPts val="600"/>
-              </a:spcAft>
-            </a:pPr>
-            <a:r>
-              <a:rPr sz="2000" b="0" i="0">
-                <a:solidFill>
-                  <a:srgbClr val="1F2A37"/>
-                </a:solidFill>
-                <a:latin typeface="Calibri"/>
-              </a:rPr>
-              <a:t>prüfen auch </a:t>
-            </a:r>
-            <a:r>
-              <a:rPr sz="2000" b="1" i="0">
-                <a:solidFill>
-                  <a:srgbClr val="1F2A37"/>
-                </a:solidFill>
-                <a:latin typeface="Calibri"/>
-              </a:rPr>
-              <a:t>Grenzfälle</a:t>
-            </a:r>
-            <a:r>
-              <a:rPr sz="2000" b="0" i="0">
-                <a:solidFill>
-                  <a:srgbClr val="1F2A37"/>
-                </a:solidFill>
-                <a:latin typeface="Calibri"/>
-              </a:rPr>
-              <a:t>: 0, genau voll, angebrochen</a:t>
-            </a:r>
-            <a:r>
-              <a:rPr sz="2000" b="0" i="0">
-                <a:solidFill>
-                  <a:srgbClr val="1F2A37"/>
-                </a:solidFill>
-                <a:latin typeface="Calibri"/>
-              </a:rPr>
-              <a:t/>
-            </a:r>
-          </a:p>
-        </p:txBody>
-      </p:sp>
-      <p:sp>
-        <p:nvSpPr>
-          <p:cNvPr id="10" name="TextBox 9"/>
+        </p:txBody>
+      </p:sp>
+      <p:sp>
+        <p:nvSpPr>
+          <p:cNvPr id="8" name="TextBox 7"/>
           <p:cNvSpPr txBox="1"/>
           <p:nvPr/>
         </p:nvSpPr>
@@ -6157,7 +6070,7 @@
         <p:spPr>
           <a:xfrm>
             <a:off x="548640" y="1417320"/>
-            <a:ext cx="5806440" cy="1301496"/>
+            <a:ext cx="7772400" cy="1636776"/>
           </a:xfrm>
           <a:prstGeom prst="rect">
             <a:avLst/>
@@ -6203,7 +6116,7 @@
         <p:spPr>
           <a:xfrm>
             <a:off x="640080" y="1490472"/>
-            <a:ext cx="5623559" cy="1210056"/>
+            <a:ext cx="7589520" cy="1545336"/>
           </a:xfrm>
           <a:prstGeom prst="rect">
             <a:avLst/>
@@ -6222,7 +6135,7 @@
               </a:lnSpc>
             </a:pPr>
             <a:r>
-              <a:rPr sz="1600" b="0" i="0">
+              <a:rPr sz="2100" b="0" i="0">
                 <a:solidFill>
                   <a:srgbClr val="A0A7B1"/>
                 </a:solidFill>
@@ -6231,7 +6144,7 @@
               <a:t>1  </a:t>
             </a:r>
             <a:r>
-              <a:rPr sz="1600" b="0" i="0">
+              <a:rPr sz="2100" b="0" i="0">
                 <a:solidFill>
                   <a:srgbClr val="1F2A37"/>
                 </a:solidFill>
@@ -6247,7 +6160,7 @@
               </a:lnSpc>
             </a:pPr>
             <a:r>
-              <a:rPr sz="1600" b="0" i="0">
+              <a:rPr sz="2100" b="0" i="0">
                 <a:solidFill>
                   <a:srgbClr val="A0A7B1"/>
                 </a:solidFill>
@@ -6256,7 +6169,7 @@
               <a:t>2  </a:t>
             </a:r>
             <a:r>
-              <a:rPr sz="1600" b="0" i="0">
+              <a:rPr sz="2100" b="0" i="0">
                 <a:solidFill>
                   <a:srgbClr val="1F2A37"/>
                 </a:solidFill>
@@ -6272,7 +6185,7 @@
               </a:lnSpc>
             </a:pPr>
             <a:r>
-              <a:rPr sz="1600" b="0" i="0">
+              <a:rPr sz="2100" b="0" i="0">
                 <a:solidFill>
                   <a:srgbClr val="A0A7B1"/>
                 </a:solidFill>
@@ -6281,7 +6194,7 @@
               <a:t>3  </a:t>
             </a:r>
             <a:r>
-              <a:rPr sz="1600" b="0" i="0">
+              <a:rPr sz="2100" b="0" i="0">
                 <a:solidFill>
                   <a:srgbClr val="1F2A37"/>
                 </a:solidFill>
@@ -6297,7 +6210,7 @@
               </a:lnSpc>
             </a:pPr>
             <a:r>
-              <a:rPr sz="1600" b="0" i="0">
+              <a:rPr sz="2100" b="0" i="0">
                 <a:solidFill>
                   <a:srgbClr val="A0A7B1"/>
                 </a:solidFill>
@@ -6306,7 +6219,7 @@
               <a:t>4  </a:t>
             </a:r>
             <a:r>
-              <a:rPr sz="1600" b="0" i="0">
+              <a:rPr sz="2100" b="0" i="0">
                 <a:solidFill>
                   <a:srgbClr val="1F2A37"/>
                 </a:solidFill>
@@ -6325,8 +6238,8 @@
         </p:nvSpPr>
         <p:spPr>
           <a:xfrm>
-            <a:off x="548640" y="2855975"/>
-            <a:ext cx="5806440" cy="3499104"/>
+            <a:off x="548640" y="3191256"/>
+            <a:ext cx="7772400" cy="3163824"/>
           </a:xfrm>
           <a:prstGeom prst="rect">
             <a:avLst/>
@@ -6345,7 +6258,7 @@
               </a:spcAft>
             </a:pPr>
             <a:r>
-              <a:rPr sz="2000" b="1" i="0">
+              <a:rPr sz="2200" b="1" i="0">
                 <a:solidFill>
                   <a:srgbClr val="B8860B"/>
                 </a:solidFill>
@@ -6354,7 +6267,7 @@
               <a:t>▸ </a:t>
             </a:r>
             <a:r>
-              <a:rPr sz="2000" b="0" i="0">
+              <a:rPr sz="2200" b="0" i="0">
                 <a:solidFill>
                   <a:srgbClr val="1F2A37"/>
                 </a:solidFill>
@@ -6363,7 +6276,7 @@
               <a:t>Ausgabe: </a:t>
             </a:r>
             <a:r>
-              <a:rPr sz="1900" b="0" i="0">
+              <a:rPr sz="2100" b="0" i="0">
                 <a:solidFill>
                   <a:srgbClr val="1F4E79"/>
                 </a:solidFill>
@@ -6372,7 +6285,7 @@
               <a:t>Fackeln fuer 7 Raeume: 3</a:t>
             </a:r>
             <a:r>
-              <a:rPr sz="2000" b="0" i="0">
+              <a:rPr sz="2200" b="0" i="0">
                 <a:solidFill>
                   <a:srgbClr val="1F2A37"/>
                 </a:solidFill>
@@ -6381,94 +6294,68 @@
               <a:t/>
             </a:r>
           </a:p>
-        </p:txBody>
-      </p:sp>
-      <p:sp>
-        <p:nvSpPr>
-          <p:cNvPr id="8" name="Rounded Rectangle 7"/>
-          <p:cNvSpPr/>
-          <p:nvPr/>
-        </p:nvSpPr>
-        <p:spPr>
-          <a:xfrm>
-            <a:off x="6629399" y="1325880"/>
-            <a:ext cx="5013655" cy="2651759"/>
-          </a:xfrm>
-          <a:prstGeom prst="roundRect">
-            <a:avLst>
-              <a:gd name="adj" fmla="val 8000"/>
-            </a:avLst>
-          </a:prstGeom>
-          <a:solidFill>
-            <a:srgbClr val="DBE7F5"/>
-          </a:solidFill>
-          <a:ln w="19050">
-            <a:solidFill>
-              <a:srgbClr val="1F4E79"/>
-            </a:solidFill>
-          </a:ln>
-          <a:effectLst/>
-        </p:spPr>
-        <p:style>
-          <a:lnRef idx="1">
-            <a:schemeClr val="accent1"/>
-          </a:lnRef>
-          <a:fillRef idx="3">
-            <a:schemeClr val="accent1"/>
-          </a:fillRef>
-          <a:effectRef idx="2">
-            <a:schemeClr val="accent1"/>
-          </a:effectRef>
-          <a:fontRef idx="minor">
-            <a:schemeClr val="lt1"/>
-          </a:fontRef>
-        </p:style>
-        <p:txBody>
-          <a:bodyPr rtlCol="0" anchor="ctr"/>
-          <a:lstStyle/>
-          <a:p>
-            <a:pPr algn="ctr"/>
-          </a:p>
-        </p:txBody>
-      </p:sp>
-      <p:sp>
-        <p:nvSpPr>
-          <p:cNvPr id="9" name="TextBox 8"/>
-          <p:cNvSpPr txBox="1"/>
-          <p:nvPr/>
-        </p:nvSpPr>
-        <p:spPr>
-          <a:xfrm>
-            <a:off x="6812279" y="1463039"/>
-            <a:ext cx="4647895" cy="2377439"/>
-          </a:xfrm>
-          <a:prstGeom prst="rect">
-            <a:avLst/>
-          </a:prstGeom>
-          <a:noFill/>
-        </p:spPr>
-        <p:txBody>
-          <a:bodyPr wrap="square" anchor="t" lIns="45720" rIns="45720">
-            <a:spAutoFit/>
-          </a:bodyPr>
-          <a:lstStyle/>
           <a:p>
             <a:pPr>
               <a:spcAft>
-                <a:spcPts val="800"/>
+                <a:spcPts val="1000"/>
               </a:spcAft>
             </a:pPr>
             <a:r>
               <a:rPr sz="2200" b="1" i="0">
                 <a:solidFill>
+                  <a:srgbClr val="B8860B"/>
+                </a:solidFill>
+                <a:latin typeface="Calibri"/>
+              </a:rPr>
+              <a:t>▸ </a:t>
+            </a:r>
+            <a:r>
+              <a:rPr sz="2100" b="0" i="0">
+                <a:solidFill>
                   <a:srgbClr val="1F4E79"/>
                 </a:solidFill>
-                <a:latin typeface="Calibri"/>
-              </a:rPr>
-              <a:t>Online-IDE</a:t>
-            </a:r>
-            <a:r>
-              <a:rPr sz="2000" b="0" i="0">
+                <a:latin typeface="Consolas"/>
+              </a:rPr>
+              <a:t>println(…)</a:t>
+            </a:r>
+            <a:r>
+              <a:rPr sz="2200" b="0" i="0">
+                <a:solidFill>
+                  <a:srgbClr val="1F2A37"/>
+                </a:solidFill>
+                <a:latin typeface="Calibri"/>
+              </a:rPr>
+              <a:t> </a:t>
+            </a:r>
+            <a:r>
+              <a:rPr sz="2200" b="1" i="0">
+                <a:solidFill>
+                  <a:srgbClr val="1F2A37"/>
+                </a:solidFill>
+                <a:latin typeface="Calibri"/>
+              </a:rPr>
+              <a:t>ohne</a:t>
+            </a:r>
+            <a:r>
+              <a:rPr sz="2200" b="0" i="0">
+                <a:solidFill>
+                  <a:srgbClr val="1F2A37"/>
+                </a:solidFill>
+                <a:latin typeface="Calibri"/>
+              </a:rPr>
+              <a:t> </a:t>
+            </a:r>
+            <a:r>
+              <a:rPr sz="2100" b="0" i="0">
+                <a:solidFill>
+                  <a:srgbClr val="1F4E79"/>
+                </a:solidFill>
+                <a:latin typeface="Consolas"/>
+              </a:rPr>
+              <a:t>System.out</a:t>
+            </a:r>
+            <a:r>
+              <a:rPr sz="2200" b="0" i="0">
                 <a:solidFill>
                   <a:srgbClr val="1F2A37"/>
                 </a:solidFill>
@@ -6480,56 +6367,47 @@
           <a:p>
             <a:pPr>
               <a:spcAft>
-                <a:spcPts val="600"/>
+                <a:spcPts val="1000"/>
               </a:spcAft>
             </a:pPr>
             <a:r>
-              <a:rPr sz="1900" b="0" i="0">
-                <a:solidFill>
-                  <a:srgbClr val="1F4E79"/>
-                </a:solidFill>
-                <a:latin typeface="Consolas"/>
-              </a:rPr>
-              <a:t>println(…)</a:t>
-            </a:r>
-            <a:r>
-              <a:rPr sz="2000" b="0" i="0">
-                <a:solidFill>
-                  <a:srgbClr val="1F2A37"/>
-                </a:solidFill>
-                <a:latin typeface="Calibri"/>
-              </a:rPr>
-              <a:t> </a:t>
-            </a:r>
-            <a:r>
-              <a:rPr sz="2000" b="1" i="0">
-                <a:solidFill>
-                  <a:srgbClr val="1F2A37"/>
-                </a:solidFill>
-                <a:latin typeface="Calibri"/>
-              </a:rPr>
-              <a:t>ohne</a:t>
-            </a:r>
-            <a:r>
-              <a:rPr sz="2000" b="0" i="0">
-                <a:solidFill>
-                  <a:srgbClr val="1F2A37"/>
-                </a:solidFill>
-                <a:latin typeface="Calibri"/>
-              </a:rPr>
-              <a:t> </a:t>
-            </a:r>
-            <a:r>
-              <a:rPr sz="1900" b="0" i="0">
-                <a:solidFill>
-                  <a:srgbClr val="1F4E79"/>
-                </a:solidFill>
-                <a:latin typeface="Consolas"/>
-              </a:rPr>
-              <a:t>System.out</a:t>
-            </a:r>
-            <a:r>
-              <a:rPr sz="2000" b="0" i="0">
+              <a:rPr sz="2200" b="1" i="0">
+                <a:solidFill>
+                  <a:srgbClr val="B8860B"/>
+                </a:solidFill>
+                <a:latin typeface="Calibri"/>
+              </a:rPr>
+              <a:t>▸ </a:t>
+            </a:r>
+            <a:r>
+              <a:rPr sz="2200" b="0" i="0">
+                <a:solidFill>
+                  <a:srgbClr val="1F2A37"/>
+                </a:solidFill>
+                <a:latin typeface="Calibri"/>
+              </a:rPr>
+              <a:t>Anweisungen </a:t>
+            </a:r>
+            <a:r>
+              <a:rPr sz="2200" b="1" i="0">
+                <a:solidFill>
+                  <a:srgbClr val="1F2A37"/>
+                </a:solidFill>
+                <a:latin typeface="Calibri"/>
+              </a:rPr>
+              <a:t>außerhalb</a:t>
+            </a:r>
+            <a:r>
+              <a:rPr sz="2200" b="0" i="0">
+                <a:solidFill>
+                  <a:srgbClr val="1F2A37"/>
+                </a:solidFill>
+                <a:latin typeface="Calibri"/>
+              </a:rPr>
+              <a:t> von Klassen = Hauptprogramm</a:t>
+            </a:r>
+            <a:r>
+              <a:rPr sz="2200" b="0" i="0">
                 <a:solidFill>
                   <a:srgbClr val="1F2A37"/>
                 </a:solidFill>
@@ -6541,38 +6419,38 @@
           <a:p>
             <a:pPr>
               <a:spcAft>
-                <a:spcPts val="600"/>
+                <a:spcPts val="1000"/>
               </a:spcAft>
             </a:pPr>
             <a:r>
-              <a:rPr sz="2000" b="0" i="0">
-                <a:solidFill>
-                  <a:srgbClr val="1F2A37"/>
-                </a:solidFill>
-                <a:latin typeface="Calibri"/>
-              </a:rPr>
-              <a:t>Anweisungen </a:t>
-            </a:r>
-            <a:r>
-              <a:rPr sz="2000" b="1" i="0">
-                <a:solidFill>
-                  <a:srgbClr val="1F2A37"/>
-                </a:solidFill>
-                <a:latin typeface="Calibri"/>
-              </a:rPr>
-              <a:t>außerhalb</a:t>
-            </a:r>
-            <a:r>
-              <a:rPr sz="2000" b="0" i="0">
-                <a:solidFill>
-                  <a:srgbClr val="1F2A37"/>
-                </a:solidFill>
-                <a:latin typeface="Calibri"/>
-              </a:rPr>
-              <a:t> von Klassen = Hauptprogramm</a:t>
-            </a:r>
-            <a:r>
-              <a:rPr sz="2000" b="0" i="0">
+              <a:rPr sz="2200" b="1" i="0">
+                <a:solidFill>
+                  <a:srgbClr val="B8860B"/>
+                </a:solidFill>
+                <a:latin typeface="Calibri"/>
+              </a:rPr>
+              <a:t>▸ </a:t>
+            </a:r>
+            <a:r>
+              <a:rPr sz="2200" b="0" i="0">
+                <a:solidFill>
+                  <a:srgbClr val="1F2A37"/>
+                </a:solidFill>
+                <a:latin typeface="Calibri"/>
+              </a:rPr>
+              <a:t>Start mit dem grünen </a:t>
+            </a:r>
+            <a:r>
+              <a:rPr sz="2200" b="1" i="0">
+                <a:solidFill>
+                  <a:srgbClr val="1F2A37"/>
+                </a:solidFill>
+                <a:latin typeface="Calibri"/>
+              </a:rPr>
+              <a:t>Startknopf</a:t>
+            </a:r>
+            <a:r>
+              <a:rPr sz="2200" b="0" i="0">
                 <a:solidFill>
                   <a:srgbClr val="1F2A37"/>
                 </a:solidFill>
@@ -6581,45 +6459,11 @@
               <a:t/>
             </a:r>
           </a:p>
-          <a:p>
-            <a:pPr>
-              <a:spcAft>
-                <a:spcPts val="600"/>
-              </a:spcAft>
-            </a:pPr>
-            <a:r>
-              <a:rPr sz="2000" b="0" i="0">
-                <a:solidFill>
-                  <a:srgbClr val="1F2A37"/>
-                </a:solidFill>
-                <a:latin typeface="Calibri"/>
-              </a:rPr>
-              <a:t>Start mit dem grünen </a:t>
-            </a:r>
-            <a:r>
-              <a:rPr sz="2000" b="1" i="0">
-                <a:solidFill>
-                  <a:srgbClr val="1F2A37"/>
-                </a:solidFill>
-                <a:latin typeface="Calibri"/>
-              </a:rPr>
-              <a:t>Startknopf</a:t>
-            </a:r>
-            <a:r>
-              <a:rPr sz="2000" b="0" i="0">
-                <a:solidFill>
-                  <a:srgbClr val="1F2A37"/>
-                </a:solidFill>
-                <a:latin typeface="Calibri"/>
-              </a:rPr>
-              <a:t/>
-            </a:r>
-          </a:p>
-        </p:txBody>
-      </p:sp>
-      <p:sp>
-        <p:nvSpPr>
-          <p:cNvPr id="10" name="TextBox 9"/>
+        </p:txBody>
+      </p:sp>
+      <p:sp>
+        <p:nvSpPr>
+          <p:cNvPr id="8" name="TextBox 7"/>
           <p:cNvSpPr txBox="1"/>
           <p:nvPr/>
         </p:nvSpPr>
@@ -6800,7 +6644,7 @@
         <p:spPr>
           <a:xfrm>
             <a:off x="548640" y="1417320"/>
-            <a:ext cx="4831080" cy="1569720"/>
+            <a:ext cx="7772400" cy="2072640"/>
           </a:xfrm>
           <a:prstGeom prst="rect">
             <a:avLst/>
@@ -6846,7 +6690,7 @@
         <p:spPr>
           <a:xfrm>
             <a:off x="640080" y="1490472"/>
-            <a:ext cx="4648200" cy="1478280"/>
+            <a:ext cx="7589520" cy="1981200"/>
           </a:xfrm>
           <a:prstGeom prst="rect">
             <a:avLst/>
@@ -6865,7 +6709,7 @@
               </a:lnSpc>
             </a:pPr>
             <a:r>
-              <a:rPr sz="1600" b="0" i="0">
+              <a:rPr sz="2200" b="0" i="0">
                 <a:solidFill>
                   <a:srgbClr val="A0A7B1"/>
                 </a:solidFill>
@@ -6874,7 +6718,7 @@
               <a:t>1  </a:t>
             </a:r>
             <a:r>
-              <a:rPr sz="1600" b="0" i="0">
+              <a:rPr sz="2200" b="0" i="0">
                 <a:solidFill>
                   <a:srgbClr val="1F2A37"/>
                 </a:solidFill>
@@ -6890,7 +6734,7 @@
               </a:lnSpc>
             </a:pPr>
             <a:r>
-              <a:rPr sz="1600" b="0" i="0">
+              <a:rPr sz="2200" b="0" i="0">
                 <a:solidFill>
                   <a:srgbClr val="A0A7B1"/>
                 </a:solidFill>
@@ -6899,7 +6743,7 @@
               <a:t>2  </a:t>
             </a:r>
             <a:r>
-              <a:rPr sz="1600" b="0" i="0">
+              <a:rPr sz="2200" b="0" i="0">
                 <a:solidFill>
                   <a:srgbClr val="1F2A37"/>
                 </a:solidFill>
@@ -6915,7 +6759,7 @@
               </a:lnSpc>
             </a:pPr>
             <a:r>
-              <a:rPr sz="1600" b="0" i="0">
+              <a:rPr sz="2200" b="0" i="0">
                 <a:solidFill>
                   <a:srgbClr val="A0A7B1"/>
                 </a:solidFill>
@@ -6924,7 +6768,7 @@
               <a:t>3  </a:t>
             </a:r>
             <a:r>
-              <a:rPr sz="1600" b="0" i="0">
+              <a:rPr sz="2200" b="0" i="0">
                 <a:solidFill>
                   <a:srgbClr val="1F2A37"/>
                 </a:solidFill>
@@ -6940,7 +6784,7 @@
               </a:lnSpc>
             </a:pPr>
             <a:r>
-              <a:rPr sz="1600" b="0" i="0">
+              <a:rPr sz="2200" b="0" i="0">
                 <a:solidFill>
                   <a:srgbClr val="A0A7B1"/>
                 </a:solidFill>
@@ -6949,7 +6793,7 @@
               <a:t>4  </a:t>
             </a:r>
             <a:r>
-              <a:rPr sz="1600" b="1" i="0">
+              <a:rPr sz="2200" b="1" i="0">
                 <a:solidFill>
                   <a:srgbClr val="C00000"/>
                 </a:solidFill>
@@ -6965,7 +6809,7 @@
               </a:lnSpc>
             </a:pPr>
             <a:r>
-              <a:rPr sz="1600" b="0" i="0">
+              <a:rPr sz="2200" b="0" i="0">
                 <a:solidFill>
                   <a:srgbClr val="A0A7B1"/>
                 </a:solidFill>
@@ -6974,7 +6818,7 @@
               <a:t>5  </a:t>
             </a:r>
             <a:r>
-              <a:rPr sz="1600" b="0" i="0">
+              <a:rPr sz="2200" b="0" i="0">
                 <a:solidFill>
                   <a:srgbClr val="1F2A37"/>
                 </a:solidFill>
@@ -6983,7 +6827,7 @@
               <a:t>println(oben);  </a:t>
             </a:r>
             <a:r>
-              <a:rPr sz="1600" b="0" i="0">
+              <a:rPr sz="2200" b="0" i="0">
                 <a:solidFill>
                   <a:srgbClr val="5F7F5F"/>
                 </a:solidFill>
@@ -7002,8 +6846,8 @@
         </p:nvSpPr>
         <p:spPr>
           <a:xfrm>
-            <a:off x="548640" y="3124200"/>
-            <a:ext cx="4831080" cy="3230880"/>
+            <a:off x="548640" y="3627120"/>
+            <a:ext cx="7772400" cy="2727959"/>
           </a:xfrm>
           <a:prstGeom prst="rect">
             <a:avLst/>
@@ -7022,7 +6866,7 @@
               </a:spcAft>
             </a:pPr>
             <a:r>
-              <a:rPr sz="2000" b="1" i="0">
+              <a:rPr sz="2200" b="1" i="0">
                 <a:solidFill>
                   <a:srgbClr val="B8860B"/>
                 </a:solidFill>
@@ -7031,70 +6875,25 @@
               <a:t>▸ </a:t>
             </a:r>
             <a:r>
-              <a:rPr sz="2000" b="0" i="0">
-                <a:solidFill>
-                  <a:srgbClr val="1F2A37"/>
-                </a:solidFill>
-                <a:latin typeface="Calibri"/>
-              </a:rPr>
-              <a:t>Nicht generisch: Inhalt ist </a:t>
-            </a:r>
-            <a:r>
-              <a:rPr sz="1900" b="0" i="0">
-                <a:solidFill>
-                  <a:srgbClr val="1F4E79"/>
-                </a:solidFill>
-                <a:latin typeface="Consolas"/>
-              </a:rPr>
-              <a:t>Object</a:t>
-            </a:r>
-            <a:r>
-              <a:rPr sz="2000" b="0" i="0">
-                <a:solidFill>
-                  <a:srgbClr val="1F2A37"/>
-                </a:solidFill>
-                <a:latin typeface="Calibri"/>
-              </a:rPr>
-              <a:t> → </a:t>
-            </a:r>
-            <a:r>
-              <a:rPr sz="2000" b="1" i="0">
-                <a:solidFill>
-                  <a:srgbClr val="1F2A37"/>
-                </a:solidFill>
-                <a:latin typeface="Calibri"/>
-              </a:rPr>
-              <a:t>Cast</a:t>
-            </a:r>
-            <a:r>
-              <a:rPr sz="2000" b="0" i="0">
-                <a:solidFill>
-                  <a:srgbClr val="1F2A37"/>
-                </a:solidFill>
-                <a:latin typeface="Calibri"/>
-              </a:rPr>
-              <a:t> nötig (</a:t>
-            </a:r>
-            <a:r>
-              <a:rPr sz="2000" b="1" i="0">
-                <a:solidFill>
-                  <a:srgbClr val="1F2A37"/>
-                </a:solidFill>
-                <a:latin typeface="Calibri"/>
-              </a:rPr>
-              <a:t>P4</a:t>
-            </a:r>
-            <a:r>
-              <a:rPr sz="2000" b="0" i="0">
-                <a:solidFill>
-                  <a:srgbClr val="1F2A37"/>
-                </a:solidFill>
-                <a:latin typeface="Calibri"/>
-              </a:rPr>
-              <a:t>)</a:t>
-            </a:r>
-            <a:r>
-              <a:rPr sz="2000" b="0" i="0">
+              <a:rPr sz="2200" b="0" i="0">
+                <a:solidFill>
+                  <a:srgbClr val="1F2A37"/>
+                </a:solidFill>
+                <a:latin typeface="Calibri"/>
+              </a:rPr>
+              <a:t>Einschalten: Rechtsklick auf den Workspace → „Einstellungen“ → Häkchen </a:t>
+            </a:r>
+            <a:r>
+              <a:rPr sz="2200" b="1" i="0">
+                <a:solidFill>
+                  <a:srgbClr val="1F2A37"/>
+                </a:solidFill>
+                <a:latin typeface="Calibri"/>
+              </a:rPr>
+              <a:t>„Niedersachsen“</a:t>
+            </a:r>
+            <a:r>
+              <a:rPr sz="2200" b="0" i="0">
                 <a:solidFill>
                   <a:srgbClr val="1F2A37"/>
                 </a:solidFill>
@@ -7103,81 +6902,10 @@
               <a:t/>
             </a:r>
           </a:p>
-        </p:txBody>
-      </p:sp>
-      <p:sp>
-        <p:nvSpPr>
-          <p:cNvPr id="8" name="Rounded Rectangle 7"/>
-          <p:cNvSpPr/>
-          <p:nvPr/>
-        </p:nvSpPr>
-        <p:spPr>
-          <a:xfrm>
-            <a:off x="5654039" y="1325880"/>
-            <a:ext cx="5989015" cy="2651759"/>
-          </a:xfrm>
-          <a:prstGeom prst="roundRect">
-            <a:avLst>
-              <a:gd name="adj" fmla="val 8000"/>
-            </a:avLst>
-          </a:prstGeom>
-          <a:solidFill>
-            <a:srgbClr val="FFF4D6"/>
-          </a:solidFill>
-          <a:ln w="19050">
-            <a:solidFill>
-              <a:srgbClr val="B8860B"/>
-            </a:solidFill>
-          </a:ln>
-          <a:effectLst/>
-        </p:spPr>
-        <p:style>
-          <a:lnRef idx="1">
-            <a:schemeClr val="accent1"/>
-          </a:lnRef>
-          <a:fillRef idx="3">
-            <a:schemeClr val="accent1"/>
-          </a:fillRef>
-          <a:effectRef idx="2">
-            <a:schemeClr val="accent1"/>
-          </a:effectRef>
-          <a:fontRef idx="minor">
-            <a:schemeClr val="lt1"/>
-          </a:fontRef>
-        </p:style>
-        <p:txBody>
-          <a:bodyPr rtlCol="0" anchor="ctr"/>
-          <a:lstStyle/>
-          <a:p>
-            <a:pPr algn="ctr"/>
-          </a:p>
-        </p:txBody>
-      </p:sp>
-      <p:sp>
-        <p:nvSpPr>
-          <p:cNvPr id="9" name="TextBox 8"/>
-          <p:cNvSpPr txBox="1"/>
-          <p:nvPr/>
-        </p:nvSpPr>
-        <p:spPr>
-          <a:xfrm>
-            <a:off x="5836920" y="1463039"/>
-            <a:ext cx="5623255" cy="2377439"/>
-          </a:xfrm>
-          <a:prstGeom prst="rect">
-            <a:avLst/>
-          </a:prstGeom>
-          <a:noFill/>
-        </p:spPr>
-        <p:txBody>
-          <a:bodyPr wrap="square" anchor="t" lIns="45720" rIns="45720">
-            <a:spAutoFit/>
-          </a:bodyPr>
-          <a:lstStyle/>
           <a:p>
             <a:pPr>
               <a:spcAft>
-                <a:spcPts val="800"/>
+                <a:spcPts val="1000"/>
               </a:spcAft>
             </a:pPr>
             <a:r>
@@ -7187,10 +6915,82 @@
                 </a:solidFill>
                 <a:latin typeface="Calibri"/>
               </a:rPr>
-              <a:t>Einschalten</a:t>
-            </a:r>
-            <a:r>
-              <a:rPr sz="2000" b="0" i="0">
+              <a:t>▸ </a:t>
+            </a:r>
+            <a:r>
+              <a:rPr sz="2200" b="0" i="0">
+                <a:solidFill>
+                  <a:srgbClr val="1F2A37"/>
+                </a:solidFill>
+                <a:latin typeface="Calibri"/>
+              </a:rPr>
+              <a:t>Dann gibt es </a:t>
+            </a:r>
+            <a:r>
+              <a:rPr sz="2100" b="0" i="0">
+                <a:solidFill>
+                  <a:srgbClr val="1F4E79"/>
+                </a:solidFill>
+                <a:latin typeface="Consolas"/>
+              </a:rPr>
+              <a:t>Stack</a:t>
+            </a:r>
+            <a:r>
+              <a:rPr sz="2200" b="0" i="0">
+                <a:solidFill>
+                  <a:srgbClr val="1F2A37"/>
+                </a:solidFill>
+                <a:latin typeface="Calibri"/>
+              </a:rPr>
+              <a:t>, </a:t>
+            </a:r>
+            <a:r>
+              <a:rPr sz="2100" b="0" i="0">
+                <a:solidFill>
+                  <a:srgbClr val="1F4E79"/>
+                </a:solidFill>
+                <a:latin typeface="Consolas"/>
+              </a:rPr>
+              <a:t>Queue</a:t>
+            </a:r>
+            <a:r>
+              <a:rPr sz="2200" b="0" i="0">
+                <a:solidFill>
+                  <a:srgbClr val="1F2A37"/>
+                </a:solidFill>
+                <a:latin typeface="Calibri"/>
+              </a:rPr>
+              <a:t>, </a:t>
+            </a:r>
+            <a:r>
+              <a:rPr sz="2100" b="0" i="0">
+                <a:solidFill>
+                  <a:srgbClr val="1F4E79"/>
+                </a:solidFill>
+                <a:latin typeface="Consolas"/>
+              </a:rPr>
+              <a:t>DynArray</a:t>
+            </a:r>
+            <a:r>
+              <a:rPr sz="2200" b="0" i="0">
+                <a:solidFill>
+                  <a:srgbClr val="1F2A37"/>
+                </a:solidFill>
+                <a:latin typeface="Calibri"/>
+              </a:rPr>
+              <a:t>, </a:t>
+            </a:r>
+            <a:r>
+              <a:rPr sz="2100" b="0" i="0">
+                <a:solidFill>
+                  <a:srgbClr val="1F4E79"/>
+                </a:solidFill>
+                <a:latin typeface="Consolas"/>
+              </a:rPr>
+              <a:t>BinTree</a:t>
+            </a:r>
+            <a:r>
+              <a:rPr sz="2200" b="0" i="0">
                 <a:solidFill>
                   <a:srgbClr val="1F2A37"/>
                 </a:solidFill>
@@ -7202,20 +7002,83 @@
           <a:p>
             <a:pPr>
               <a:spcAft>
-                <a:spcPts val="600"/>
+                <a:spcPts val="1000"/>
               </a:spcAft>
             </a:pPr>
             <a:r>
-              <a:rPr sz="2000" b="0" i="0">
-                <a:solidFill>
-                  <a:srgbClr val="1F2A37"/>
-                </a:solidFill>
-                <a:latin typeface="Calibri"/>
-              </a:rPr>
-              <a:t>Rechtsklick auf den Workspace → „Einstellungen“</a:t>
-            </a:r>
-            <a:r>
-              <a:rPr sz="2000" b="0" i="0">
+              <a:rPr sz="2200" b="1" i="0">
+                <a:solidFill>
+                  <a:srgbClr val="B8860B"/>
+                </a:solidFill>
+                <a:latin typeface="Calibri"/>
+              </a:rPr>
+              <a:t>▸ </a:t>
+            </a:r>
+            <a:r>
+              <a:rPr sz="2200" b="0" i="0">
+                <a:solidFill>
+                  <a:srgbClr val="1F2A37"/>
+                </a:solidFill>
+                <a:latin typeface="Calibri"/>
+              </a:rPr>
+              <a:t>Nicht generisch: Inhalt ist </a:t>
+            </a:r>
+            <a:r>
+              <a:rPr sz="2100" b="0" i="0">
+                <a:solidFill>
+                  <a:srgbClr val="1F4E79"/>
+                </a:solidFill>
+                <a:latin typeface="Consolas"/>
+              </a:rPr>
+              <a:t>Object</a:t>
+            </a:r>
+            <a:r>
+              <a:rPr sz="2200" b="0" i="0">
+                <a:solidFill>
+                  <a:srgbClr val="1F2A37"/>
+                </a:solidFill>
+                <a:latin typeface="Calibri"/>
+              </a:rPr>
+              <a:t> → </a:t>
+            </a:r>
+            <a:r>
+              <a:rPr sz="2200" b="1" i="0">
+                <a:solidFill>
+                  <a:srgbClr val="1F2A37"/>
+                </a:solidFill>
+                <a:latin typeface="Calibri"/>
+              </a:rPr>
+              <a:t>Cast</a:t>
+            </a:r>
+            <a:r>
+              <a:rPr sz="2200" b="0" i="0">
+                <a:solidFill>
+                  <a:srgbClr val="1F2A37"/>
+                </a:solidFill>
+                <a:latin typeface="Calibri"/>
+              </a:rPr>
+              <a:t> nötig (</a:t>
+            </a:r>
+            <a:r>
+              <a:rPr sz="2200" b="1" i="0">
+                <a:solidFill>
+                  <a:srgbClr val="1F2A37"/>
+                </a:solidFill>
+                <a:latin typeface="Calibri"/>
+              </a:rPr>
+              <a:t>P4</a:t>
+            </a:r>
+            <a:r>
+              <a:rPr sz="2200" b="0" i="0">
+                <a:solidFill>
+                  <a:srgbClr val="1F2A37"/>
+                </a:solidFill>
+                <a:latin typeface="Calibri"/>
+              </a:rPr>
+              <a:t>)</a:t>
+            </a:r>
+            <a:r>
+              <a:rPr sz="2200" b="0" i="0">
                 <a:solidFill>
                   <a:srgbClr val="1F2A37"/>
                 </a:solidFill>
@@ -7224,133 +7087,11 @@
               <a:t/>
             </a:r>
           </a:p>
-          <a:p>
-            <a:pPr>
-              <a:spcAft>
-                <a:spcPts val="600"/>
-              </a:spcAft>
-            </a:pPr>
-            <a:r>
-              <a:rPr sz="2000" b="0" i="0">
-                <a:solidFill>
-                  <a:srgbClr val="1F2A37"/>
-                </a:solidFill>
-                <a:latin typeface="Calibri"/>
-              </a:rPr>
-              <a:t>Häkchen bei </a:t>
-            </a:r>
-            <a:r>
-              <a:rPr sz="2000" b="1" i="0">
-                <a:solidFill>
-                  <a:srgbClr val="1F2A37"/>
-                </a:solidFill>
-                <a:latin typeface="Calibri"/>
-              </a:rPr>
-              <a:t>„Niedersachsen“</a:t>
-            </a:r>
-            <a:r>
-              <a:rPr sz="2000" b="0" i="0">
-                <a:solidFill>
-                  <a:srgbClr val="1F2A37"/>
-                </a:solidFill>
-                <a:latin typeface="Calibri"/>
-              </a:rPr>
-              <a:t/>
-            </a:r>
-          </a:p>
-          <a:p>
-            <a:pPr>
-              <a:spcAft>
-                <a:spcPts val="600"/>
-              </a:spcAft>
-            </a:pPr>
-            <a:r>
-              <a:rPr sz="2000" b="0" i="0">
-                <a:solidFill>
-                  <a:srgbClr val="1F2A37"/>
-                </a:solidFill>
-                <a:latin typeface="Calibri"/>
-              </a:rPr>
-              <a:t>Dann gibt es </a:t>
-            </a:r>
-            <a:r>
-              <a:rPr sz="1900" b="0" i="0">
-                <a:solidFill>
-                  <a:srgbClr val="1F4E79"/>
-                </a:solidFill>
-                <a:latin typeface="Consolas"/>
-              </a:rPr>
-              <a:t>Stack</a:t>
-            </a:r>
-            <a:r>
-              <a:rPr sz="2000" b="0" i="0">
-                <a:solidFill>
-                  <a:srgbClr val="1F2A37"/>
-                </a:solidFill>
-                <a:latin typeface="Calibri"/>
-              </a:rPr>
-              <a:t>, </a:t>
-            </a:r>
-            <a:r>
-              <a:rPr sz="1900" b="0" i="0">
-                <a:solidFill>
-                  <a:srgbClr val="1F4E79"/>
-                </a:solidFill>
-                <a:latin typeface="Consolas"/>
-              </a:rPr>
-              <a:t>Queue</a:t>
-            </a:r>
-            <a:r>
-              <a:rPr sz="2000" b="0" i="0">
-                <a:solidFill>
-                  <a:srgbClr val="1F2A37"/>
-                </a:solidFill>
-                <a:latin typeface="Calibri"/>
-              </a:rPr>
-              <a:t>, </a:t>
-            </a:r>
-            <a:r>
-              <a:rPr sz="1900" b="0" i="0">
-                <a:solidFill>
-                  <a:srgbClr val="1F4E79"/>
-                </a:solidFill>
-                <a:latin typeface="Consolas"/>
-              </a:rPr>
-              <a:t>DynArray</a:t>
-            </a:r>
-            <a:r>
-              <a:rPr sz="2000" b="0" i="0">
-                <a:solidFill>
-                  <a:srgbClr val="1F2A37"/>
-                </a:solidFill>
-                <a:latin typeface="Calibri"/>
-              </a:rPr>
-              <a:t>, </a:t>
-            </a:r>
-            <a:r>
-              <a:rPr sz="1900" b="0" i="0">
-                <a:solidFill>
-                  <a:srgbClr val="1F4E79"/>
-                </a:solidFill>
-                <a:latin typeface="Consolas"/>
-              </a:rPr>
-              <a:t>BinTree</a:t>
-            </a:r>
-            <a:r>
-              <a:rPr sz="2000" b="0" i="0">
-                <a:solidFill>
-                  <a:srgbClr val="1F2A37"/>
-                </a:solidFill>
-                <a:latin typeface="Calibri"/>
-              </a:rPr>
-              <a:t/>
-            </a:r>
-          </a:p>
-        </p:txBody>
-      </p:sp>
-      <p:sp>
-        <p:nvSpPr>
-          <p:cNvPr id="10" name="TextBox 9"/>
+        </p:txBody>
+      </p:sp>
+      <p:sp>
+        <p:nvSpPr>
+          <p:cNvPr id="8" name="TextBox 7"/>
           <p:cNvSpPr txBox="1"/>
           <p:nvPr/>
         </p:nvSpPr>
@@ -7531,7 +7272,7 @@
         <p:spPr>
           <a:xfrm>
             <a:off x="548640" y="1417320"/>
-            <a:ext cx="4465320" cy="1301496"/>
+            <a:ext cx="7772400" cy="1703832"/>
           </a:xfrm>
           <a:prstGeom prst="rect">
             <a:avLst/>
@@ -7577,7 +7318,7 @@
         <p:spPr>
           <a:xfrm>
             <a:off x="640080" y="1490472"/>
-            <a:ext cx="4282439" cy="1210056"/>
+            <a:ext cx="7589520" cy="1612392"/>
           </a:xfrm>
           <a:prstGeom prst="rect">
             <a:avLst/>
@@ -7596,7 +7337,7 @@
               </a:lnSpc>
             </a:pPr>
             <a:r>
-              <a:rPr sz="1600" b="0" i="0">
+              <a:rPr sz="2200" b="0" i="0">
                 <a:solidFill>
                   <a:srgbClr val="A0A7B1"/>
                 </a:solidFill>
@@ -7605,7 +7346,7 @@
               <a:t>1  </a:t>
             </a:r>
             <a:r>
-              <a:rPr sz="1600" b="0" i="0">
+              <a:rPr sz="2200" b="0" i="0">
                 <a:solidFill>
                   <a:srgbClr val="1F2A37"/>
                 </a:solidFill>
@@ -7621,7 +7362,7 @@
               </a:lnSpc>
             </a:pPr>
             <a:r>
-              <a:rPr sz="1600" b="0" i="0">
+              <a:rPr sz="2200" b="0" i="0">
                 <a:solidFill>
                   <a:srgbClr val="A0A7B1"/>
                 </a:solidFill>
@@ -7630,7 +7371,7 @@
               <a:t>2  </a:t>
             </a:r>
             <a:r>
-              <a:rPr sz="1600" b="0" i="0">
+              <a:rPr sz="2200" b="0" i="0">
                 <a:solidFill>
                   <a:srgbClr val="1F2A37"/>
                 </a:solidFill>
@@ -7646,7 +7387,7 @@
               </a:lnSpc>
             </a:pPr>
             <a:r>
-              <a:rPr sz="1600" b="0" i="0">
+              <a:rPr sz="2200" b="0" i="0">
                 <a:solidFill>
                   <a:srgbClr val="A0A7B1"/>
                 </a:solidFill>
@@ -7655,7 +7396,7 @@
               <a:t>3  </a:t>
             </a:r>
             <a:r>
-              <a:rPr sz="1600" b="1" i="0">
+              <a:rPr sz="2200" b="1" i="0">
                 <a:solidFill>
                   <a:srgbClr val="C00000"/>
                 </a:solidFill>
@@ -7671,7 +7412,7 @@
               </a:lnSpc>
             </a:pPr>
             <a:r>
-              <a:rPr sz="1600" b="0" i="0">
+              <a:rPr sz="2200" b="0" i="0">
                 <a:solidFill>
                   <a:srgbClr val="A0A7B1"/>
                 </a:solidFill>
@@ -7680,7 +7421,7 @@
               <a:t>4  </a:t>
             </a:r>
             <a:r>
-              <a:rPr sz="1600" b="0" i="0">
+              <a:rPr sz="2200" b="0" i="0">
                 <a:solidFill>
                   <a:srgbClr val="1F2A37"/>
                 </a:solidFill>
@@ -7699,8 +7440,8 @@
         </p:nvSpPr>
         <p:spPr>
           <a:xfrm>
-            <a:off x="548640" y="2855975"/>
-            <a:ext cx="4465320" cy="3499104"/>
+            <a:off x="548640" y="3258312"/>
+            <a:ext cx="7772400" cy="3096768"/>
           </a:xfrm>
           <a:prstGeom prst="rect">
             <a:avLst/>
@@ -7719,7 +7460,7 @@
               </a:spcAft>
             </a:pPr>
             <a:r>
-              <a:rPr sz="2000" b="1" i="0">
+              <a:rPr sz="2200" b="1" i="0">
                 <a:solidFill>
                   <a:srgbClr val="B8860B"/>
                 </a:solidFill>
@@ -7728,7 +7469,7 @@
               <a:t>▸ </a:t>
             </a:r>
             <a:r>
-              <a:rPr sz="2000" b="0" i="0">
+              <a:rPr sz="2200" b="0" i="0">
                 <a:solidFill>
                   <a:srgbClr val="1F2A37"/>
                 </a:solidFill>
@@ -7737,7 +7478,7 @@
               <a:t>Zeile 3: Online-IDE </a:t>
             </a:r>
             <a:r>
-              <a:rPr sz="2000" b="1" i="0">
+              <a:rPr sz="2200" b="1" i="0">
                 <a:solidFill>
                   <a:srgbClr val="1F2A37"/>
                 </a:solidFill>
@@ -7746,7 +7487,7 @@
               <a:t>true</a:t>
             </a:r>
             <a:r>
-              <a:rPr sz="2000" b="0" i="0">
+              <a:rPr sz="2200" b="0" i="0">
                 <a:solidFill>
                   <a:srgbClr val="1F2A37"/>
                 </a:solidFill>
@@ -7755,7 +7496,7 @@
               <a:t> – echtes Java </a:t>
             </a:r>
             <a:r>
-              <a:rPr sz="2000" b="1" i="0">
+              <a:rPr sz="2200" b="1" i="0">
                 <a:solidFill>
                   <a:srgbClr val="1F2A37"/>
                 </a:solidFill>
@@ -7764,7 +7505,7 @@
               <a:t>false</a:t>
             </a:r>
             <a:r>
-              <a:rPr sz="2000" b="0" i="0">
+              <a:rPr sz="2200" b="0" i="0">
                 <a:solidFill>
                   <a:srgbClr val="1F2A37"/>
                 </a:solidFill>
@@ -7780,7 +7521,7 @@
               </a:spcAft>
             </a:pPr>
             <a:r>
-              <a:rPr sz="2000" b="1" i="0">
+              <a:rPr sz="2200" b="1" i="0">
                 <a:solidFill>
                   <a:srgbClr val="B8860B"/>
                 </a:solidFill>
@@ -7789,7 +7530,7 @@
               <a:t>▸ </a:t>
             </a:r>
             <a:r>
-              <a:rPr sz="2000" b="0" i="0">
+              <a:rPr sz="2200" b="0" i="0">
                 <a:solidFill>
                   <a:srgbClr val="1F2A37"/>
                 </a:solidFill>
@@ -7798,7 +7539,7 @@
               <a:t>Zeile 4: überall </a:t>
             </a:r>
             <a:r>
-              <a:rPr sz="2000" b="1" i="0">
+              <a:rPr sz="2200" b="1" i="0">
                 <a:solidFill>
                   <a:srgbClr val="1F2A37"/>
                 </a:solidFill>
@@ -7807,7 +7548,7 @@
               <a:t>true</a:t>
             </a:r>
             <a:r>
-              <a:rPr sz="2000" b="0" i="0">
+              <a:rPr sz="2200" b="0" i="0">
                 <a:solidFill>
                   <a:srgbClr val="1F2A37"/>
                 </a:solidFill>
@@ -7816,94 +7557,77 @@
               <a:t/>
             </a:r>
           </a:p>
-        </p:txBody>
-      </p:sp>
-      <p:sp>
-        <p:nvSpPr>
-          <p:cNvPr id="8" name="Rounded Rectangle 7"/>
-          <p:cNvSpPr/>
-          <p:nvPr/>
-        </p:nvSpPr>
-        <p:spPr>
-          <a:xfrm>
-            <a:off x="5288279" y="1325880"/>
-            <a:ext cx="6354775" cy="2651759"/>
-          </a:xfrm>
-          <a:prstGeom prst="roundRect">
-            <a:avLst>
-              <a:gd name="adj" fmla="val 8000"/>
-            </a:avLst>
-          </a:prstGeom>
-          <a:solidFill>
-            <a:srgbClr val="FBE3E3"/>
-          </a:solidFill>
-          <a:ln w="19050">
-            <a:solidFill>
-              <a:srgbClr val="C00000"/>
-            </a:solidFill>
-          </a:ln>
-          <a:effectLst/>
-        </p:spPr>
-        <p:style>
-          <a:lnRef idx="1">
-            <a:schemeClr val="accent1"/>
-          </a:lnRef>
-          <a:fillRef idx="3">
-            <a:schemeClr val="accent1"/>
-          </a:fillRef>
-          <a:effectRef idx="2">
-            <a:schemeClr val="accent1"/>
-          </a:effectRef>
-          <a:fontRef idx="minor">
-            <a:schemeClr val="lt1"/>
-          </a:fontRef>
-        </p:style>
-        <p:txBody>
-          <a:bodyPr rtlCol="0" anchor="ctr"/>
-          <a:lstStyle/>
-          <a:p>
-            <a:pPr algn="ctr"/>
-          </a:p>
-        </p:txBody>
-      </p:sp>
-      <p:sp>
-        <p:nvSpPr>
-          <p:cNvPr id="9" name="TextBox 8"/>
-          <p:cNvSpPr txBox="1"/>
-          <p:nvPr/>
-        </p:nvSpPr>
-        <p:spPr>
-          <a:xfrm>
-            <a:off x="5471159" y="1463039"/>
-            <a:ext cx="5989015" cy="2377439"/>
-          </a:xfrm>
-          <a:prstGeom prst="rect">
-            <a:avLst/>
-          </a:prstGeom>
-          <a:noFill/>
-        </p:spPr>
-        <p:txBody>
-          <a:bodyPr wrap="square" anchor="t" lIns="45720" rIns="45720">
-            <a:spAutoFit/>
-          </a:bodyPr>
-          <a:lstStyle/>
           <a:p>
             <a:pPr>
               <a:spcAft>
-                <a:spcPts val="800"/>
+                <a:spcPts val="1000"/>
               </a:spcAft>
             </a:pPr>
             <a:r>
               <a:rPr sz="2200" b="1" i="0">
                 <a:solidFill>
-                  <a:srgbClr val="C00000"/>
+                  <a:srgbClr val="B8860B"/>
+                </a:solidFill>
+                <a:latin typeface="Calibri"/>
+              </a:rPr>
+              <a:t>▸ </a:t>
+            </a:r>
+            <a:r>
+              <a:rPr sz="2200" b="1" i="0">
+                <a:solidFill>
+                  <a:srgbClr val="1F2A37"/>
                 </a:solidFill>
                 <a:latin typeface="Calibri"/>
               </a:rPr>
               <a:t>P5</a:t>
             </a:r>
             <a:r>
-              <a:rPr sz="2000" b="0" i="0">
+              <a:rPr sz="2200" b="0" i="0">
+                <a:solidFill>
+                  <a:srgbClr val="1F2A37"/>
+                </a:solidFill>
+                <a:latin typeface="Calibri"/>
+              </a:rPr>
+              <a:t>: Die Tests bleiben grün – im Abitur gilt Java: </a:t>
+            </a:r>
+            <a:r>
+              <a:rPr sz="2200" b="1" i="0">
+                <a:solidFill>
+                  <a:srgbClr val="1F2A37"/>
+                </a:solidFill>
+                <a:latin typeface="Calibri"/>
+              </a:rPr>
+              <a:t>immer</a:t>
+            </a:r>
+            <a:r>
+              <a:rPr sz="2200" b="0" i="0">
+                <a:solidFill>
+                  <a:srgbClr val="1F2A37"/>
+                </a:solidFill>
+                <a:latin typeface="Calibri"/>
+              </a:rPr>
+              <a:t> </a:t>
+            </a:r>
+            <a:r>
+              <a:rPr sz="2100" b="0" i="0">
+                <a:solidFill>
+                  <a:srgbClr val="1F4E79"/>
+                </a:solidFill>
+                <a:latin typeface="Consolas"/>
+              </a:rPr>
+              <a:t>equals</a:t>
+            </a:r>
+            <a:r>
+              <a:rPr sz="2200" b="0" i="0">
+                <a:solidFill>
+                  <a:srgbClr val="1F2A37"/>
+                </a:solidFill>
+                <a:latin typeface="Calibri"/>
+              </a:rPr>
+              <a:t>!</a:t>
+            </a:r>
+            <a:r>
+              <a:rPr sz="2200" b="0" i="0">
                 <a:solidFill>
                   <a:srgbClr val="1F2A37"/>
                 </a:solidFill>
@@ -7912,133 +7636,11 @@
               <a:t/>
             </a:r>
           </a:p>
-          <a:p>
-            <a:pPr>
-              <a:spcAft>
-                <a:spcPts val="600"/>
-              </a:spcAft>
-            </a:pPr>
-            <a:r>
-              <a:rPr sz="2000" b="0" i="0">
-                <a:solidFill>
-                  <a:srgbClr val="1F2A37"/>
-                </a:solidFill>
-                <a:latin typeface="Calibri"/>
-              </a:rPr>
-              <a:t>Die Online-IDE vergleicht mit </a:t>
-            </a:r>
-            <a:r>
-              <a:rPr sz="1900" b="0" i="0">
-                <a:solidFill>
-                  <a:srgbClr val="1F4E79"/>
-                </a:solidFill>
-                <a:latin typeface="Consolas"/>
-              </a:rPr>
-              <a:t>==</a:t>
-            </a:r>
-            <a:r>
-              <a:rPr sz="2000" b="0" i="0">
-                <a:solidFill>
-                  <a:srgbClr val="1F2A37"/>
-                </a:solidFill>
-                <a:latin typeface="Calibri"/>
-              </a:rPr>
-              <a:t> den </a:t>
-            </a:r>
-            <a:r>
-              <a:rPr sz="2000" b="1" i="0">
-                <a:solidFill>
-                  <a:srgbClr val="1F2A37"/>
-                </a:solidFill>
-                <a:latin typeface="Calibri"/>
-              </a:rPr>
-              <a:t>Inhalt</a:t>
-            </a:r>
-            <a:r>
-              <a:rPr sz="2000" b="0" i="0">
-                <a:solidFill>
-                  <a:srgbClr val="1F2A37"/>
-                </a:solidFill>
-                <a:latin typeface="Calibri"/>
-              </a:rPr>
-              <a:t> – die Tests bleiben grün.</a:t>
-            </a:r>
-            <a:r>
-              <a:rPr sz="2000" b="0" i="0">
-                <a:solidFill>
-                  <a:srgbClr val="1F2A37"/>
-                </a:solidFill>
-                <a:latin typeface="Calibri"/>
-              </a:rPr>
-              <a:t/>
-            </a:r>
-          </a:p>
-          <a:p>
-            <a:pPr>
-              <a:spcAft>
-                <a:spcPts val="600"/>
-              </a:spcAft>
-            </a:pPr>
-            <a:r>
-              <a:rPr sz="2000" b="0" i="0">
-                <a:solidFill>
-                  <a:srgbClr val="1F2A37"/>
-                </a:solidFill>
-                <a:latin typeface="Calibri"/>
-              </a:rPr>
-              <a:t>Im Abitur gilt Java: </a:t>
-            </a:r>
-            <a:r>
-              <a:rPr sz="2000" b="1" i="0">
-                <a:solidFill>
-                  <a:srgbClr val="1F2A37"/>
-                </a:solidFill>
-                <a:latin typeface="Calibri"/>
-              </a:rPr>
-              <a:t>immer</a:t>
-            </a:r>
-            <a:r>
-              <a:rPr sz="2000" b="0" i="0">
-                <a:solidFill>
-                  <a:srgbClr val="1F2A37"/>
-                </a:solidFill>
-                <a:latin typeface="Calibri"/>
-              </a:rPr>
-              <a:t> </a:t>
-            </a:r>
-            <a:r>
-              <a:rPr sz="1900" b="0" i="0">
-                <a:solidFill>
-                  <a:srgbClr val="1F4E79"/>
-                </a:solidFill>
-                <a:latin typeface="Consolas"/>
-              </a:rPr>
-              <a:t>equals</a:t>
-            </a:r>
-            <a:r>
-              <a:rPr sz="2000" b="0" i="0">
-                <a:solidFill>
-                  <a:srgbClr val="1F2A37"/>
-                </a:solidFill>
-                <a:latin typeface="Calibri"/>
-              </a:rPr>
-              <a:t>!</a:t>
-            </a:r>
-            <a:r>
-              <a:rPr sz="2000" b="0" i="0">
-                <a:solidFill>
-                  <a:srgbClr val="1F2A37"/>
-                </a:solidFill>
-                <a:latin typeface="Calibri"/>
-              </a:rPr>
-              <a:t/>
-            </a:r>
-          </a:p>
-        </p:txBody>
-      </p:sp>
-      <p:sp>
-        <p:nvSpPr>
-          <p:cNvPr id="10" name="TextBox 9"/>
+        </p:txBody>
+      </p:sp>
+      <p:sp>
+        <p:nvSpPr>
+          <p:cNvPr id="8" name="TextBox 7"/>
           <p:cNvSpPr txBox="1"/>
           <p:nvPr/>
         </p:nvSpPr>
@@ -10885,7 +10487,7 @@
         <p:spPr>
           <a:xfrm>
             <a:off x="548640" y="1417320"/>
-            <a:ext cx="4465320" cy="4520184"/>
+            <a:ext cx="5394960" cy="4050792"/>
           </a:xfrm>
           <a:prstGeom prst="rect">
             <a:avLst/>
@@ -10931,7 +10533,7 @@
         <p:spPr>
           <a:xfrm>
             <a:off x="640080" y="1490472"/>
-            <a:ext cx="4282439" cy="4428744"/>
+            <a:ext cx="5212080" cy="3959352"/>
           </a:xfrm>
           <a:prstGeom prst="rect">
             <a:avLst/>
@@ -10950,13 +10552,13 @@
               </a:lnSpc>
             </a:pPr>
             <a:r>
-              <a:rPr sz="1600" b="0" i="0">
+              <a:rPr sz="1900" b="0" i="0">
                 <a:solidFill>
                   <a:srgbClr val="1F2A37"/>
                 </a:solidFill>
                 <a:latin typeface="Consolas"/>
               </a:rPr>
-              <a:t>// ===============================</a:t>
+              <a:t>// ==============================</a:t>
             </a:r>
           </a:p>
           <a:p>
@@ -10966,7 +10568,7 @@
               </a:lnSpc>
             </a:pPr>
             <a:r>
-              <a:rPr sz="1600" b="0" i="0">
+              <a:rPr sz="1900" b="0" i="0">
                 <a:solidFill>
                   <a:srgbClr val="1F2A37"/>
                 </a:solidFill>
@@ -10982,7 +10584,7 @@
               </a:lnSpc>
             </a:pPr>
             <a:r>
-              <a:rPr sz="1600" b="0" i="0">
+              <a:rPr sz="1900" b="0" i="0">
                 <a:solidFill>
                   <a:srgbClr val="1F2A37"/>
                 </a:solidFill>
@@ -10998,13 +10600,13 @@
               </a:lnSpc>
             </a:pPr>
             <a:r>
-              <a:rPr sz="1600" b="0" i="0">
+              <a:rPr sz="1900" b="0" i="0">
                 <a:solidFill>
                   <a:srgbClr val="1F2A37"/>
                 </a:solidFill>
                 <a:latin typeface="Consolas"/>
               </a:rPr>
-              <a:t>// ===============================</a:t>
+              <a:t>// ==============================</a:t>
             </a:r>
           </a:p>
           <a:p>
@@ -11014,13 +10616,13 @@
               </a:lnSpc>
             </a:pPr>
             <a:r>
-              <a:rPr sz="1600" b="0" i="0">
+              <a:rPr sz="1900" b="0" i="0">
                 <a:solidFill>
                   <a:srgbClr val="1F2A37"/>
                 </a:solidFill>
                 <a:latin typeface="Consolas"/>
               </a:rPr>
-              <a:t/>
+              <a:t>// GERÜST – hier nichts veraendern</a:t>
             </a:r>
           </a:p>
           <a:p>
@@ -11030,13 +10632,13 @@
               </a:lnSpc>
             </a:pPr>
             <a:r>
-              <a:rPr sz="1600" b="0" i="0">
+              <a:rPr sz="1900" b="0" i="0">
                 <a:solidFill>
                   <a:srgbClr val="1F2A37"/>
                 </a:solidFill>
                 <a:latin typeface="Consolas"/>
               </a:rPr>
-              <a:t>// GERÜST – hier nichts veraendern</a:t>
+              <a:t>class Anzeige { … }</a:t>
             </a:r>
           </a:p>
           <a:p>
@@ -11046,13 +10648,13 @@
               </a:lnSpc>
             </a:pPr>
             <a:r>
-              <a:rPr sz="1600" b="0" i="0">
-                <a:solidFill>
-                  <a:srgbClr val="1F2A37"/>
+              <a:rPr sz="1900" b="1" i="0">
+                <a:solidFill>
+                  <a:srgbClr val="C00000"/>
                 </a:solidFill>
                 <a:latin typeface="Consolas"/>
               </a:rPr>
-              <a:t>class Anzeige { … }</a:t>
+              <a:t>// DEIN TEIL – hier arbeitest du!</a:t>
             </a:r>
           </a:p>
           <a:p>
@@ -11062,13 +10664,13 @@
               </a:lnSpc>
             </a:pPr>
             <a:r>
-              <a:rPr sz="1600" b="0" i="0">
-                <a:solidFill>
-                  <a:srgbClr val="1F2A37"/>
+              <a:rPr sz="1900" b="1" i="0">
+                <a:solidFill>
+                  <a:srgbClr val="C00000"/>
                 </a:solidFill>
                 <a:latin typeface="Consolas"/>
               </a:rPr>
-              <a:t/>
+              <a:t>class Werkstatt { … }</a:t>
             </a:r>
           </a:p>
           <a:p>
@@ -11078,13 +10680,13 @@
               </a:lnSpc>
             </a:pPr>
             <a:r>
-              <a:rPr sz="1600" b="1" i="0">
-                <a:solidFill>
-                  <a:srgbClr val="C00000"/>
+              <a:rPr sz="1900" b="0" i="0">
+                <a:solidFill>
+                  <a:srgbClr val="1F2A37"/>
                 </a:solidFill>
                 <a:latin typeface="Consolas"/>
               </a:rPr>
-              <a:t>// DEIN TEIL – hier arbeitest du!</a:t>
+              <a:t>// TESTS – hier nichts veraendern!</a:t>
             </a:r>
           </a:p>
           <a:p>
@@ -11094,13 +10696,13 @@
               </a:lnSpc>
             </a:pPr>
             <a:r>
-              <a:rPr sz="1600" b="1" i="0">
-                <a:solidFill>
-                  <a:srgbClr val="C00000"/>
+              <a:rPr sz="1900" b="0" i="0">
+                <a:solidFill>
+                  <a:srgbClr val="1F2A37"/>
                 </a:solidFill>
                 <a:latin typeface="Consolas"/>
               </a:rPr>
-              <a:t>class Werkstatt { … }</a:t>
+              <a:t>class …Test { … }</a:t>
             </a:r>
           </a:p>
           <a:p>
@@ -11110,13 +10712,13 @@
               </a:lnSpc>
             </a:pPr>
             <a:r>
-              <a:rPr sz="1600" b="0" i="0">
+              <a:rPr sz="1900" b="0" i="0">
                 <a:solidFill>
                   <a:srgbClr val="1F2A37"/>
                 </a:solidFill>
                 <a:latin typeface="Consolas"/>
               </a:rPr>
-              <a:t/>
+              <a:t>// Programmstart</a:t>
             </a:r>
           </a:p>
           <a:p>
@@ -11126,71 +10728,7 @@
               </a:lnSpc>
             </a:pPr>
             <a:r>
-              <a:rPr sz="1600" b="0" i="0">
-                <a:solidFill>
-                  <a:srgbClr val="1F2A37"/>
-                </a:solidFill>
-                <a:latin typeface="Consolas"/>
-              </a:rPr>
-              <a:t>// TESTS – hier nichts veraendern!</a:t>
-            </a:r>
-          </a:p>
-          <a:p>
-            <a:pPr>
-              <a:lnSpc>
-                <a:spcPct val="100000"/>
-              </a:lnSpc>
-            </a:pPr>
-            <a:r>
-              <a:rPr sz="1600" b="0" i="0">
-                <a:solidFill>
-                  <a:srgbClr val="1F2A37"/>
-                </a:solidFill>
-                <a:latin typeface="Consolas"/>
-              </a:rPr>
-              <a:t>class …Test { … }</a:t>
-            </a:r>
-          </a:p>
-          <a:p>
-            <a:pPr>
-              <a:lnSpc>
-                <a:spcPct val="100000"/>
-              </a:lnSpc>
-            </a:pPr>
-            <a:r>
-              <a:rPr sz="1600" b="0" i="0">
-                <a:solidFill>
-                  <a:srgbClr val="1F2A37"/>
-                </a:solidFill>
-                <a:latin typeface="Consolas"/>
-              </a:rPr>
-              <a:t/>
-            </a:r>
-          </a:p>
-          <a:p>
-            <a:pPr>
-              <a:lnSpc>
-                <a:spcPct val="100000"/>
-              </a:lnSpc>
-            </a:pPr>
-            <a:r>
-              <a:rPr sz="1600" b="0" i="0">
-                <a:solidFill>
-                  <a:srgbClr val="1F2A37"/>
-                </a:solidFill>
-                <a:latin typeface="Consolas"/>
-              </a:rPr>
-              <a:t>// Programmstart</a:t>
-            </a:r>
-          </a:p>
-          <a:p>
-            <a:pPr>
-              <a:lnSpc>
-                <a:spcPct val="100000"/>
-              </a:lnSpc>
-            </a:pPr>
-            <a:r>
-              <a:rPr sz="1600" b="0" i="0">
+              <a:rPr sz="1900" b="0" i="0">
                 <a:solidFill>
                   <a:srgbClr val="1F2A37"/>
                 </a:solidFill>
@@ -11209,8 +10747,8 @@
         </p:nvSpPr>
         <p:spPr>
           <a:xfrm>
-            <a:off x="5288279" y="1325880"/>
-            <a:ext cx="6354775" cy="2651759"/>
+            <a:off x="6217920" y="1325880"/>
+            <a:ext cx="5425135" cy="2651759"/>
           </a:xfrm>
           <a:prstGeom prst="roundRect">
             <a:avLst>
@@ -11257,8 +10795,8 @@
         </p:nvSpPr>
         <p:spPr>
           <a:xfrm>
-            <a:off x="5471159" y="1463039"/>
-            <a:ext cx="5989015" cy="2377439"/>
+            <a:off x="6400800" y="1463039"/>
+            <a:ext cx="5059375" cy="2377439"/>
           </a:xfrm>
           <a:prstGeom prst="rect">
             <a:avLst/>
@@ -11650,7 +11188,7 @@
         <p:spPr>
           <a:xfrm>
             <a:off x="548640" y="1417320"/>
-            <a:ext cx="5928359" cy="2642616"/>
+            <a:ext cx="7772400" cy="3396996"/>
           </a:xfrm>
           <a:prstGeom prst="rect">
             <a:avLst/>
@@ -11696,7 +11234,7 @@
         <p:spPr>
           <a:xfrm>
             <a:off x="640080" y="1490472"/>
-            <a:ext cx="5745479" cy="2551176"/>
+            <a:ext cx="7589520" cy="3305556"/>
           </a:xfrm>
           <a:prstGeom prst="rect">
             <a:avLst/>
@@ -11715,7 +11253,7 @@
               </a:lnSpc>
             </a:pPr>
             <a:r>
-              <a:rPr sz="1600" b="0" i="0">
+              <a:rPr sz="2100" b="0" i="0">
                 <a:solidFill>
                   <a:srgbClr val="A0A7B1"/>
                 </a:solidFill>
@@ -11724,7 +11262,7 @@
               <a:t>1  </a:t>
             </a:r>
             <a:r>
-              <a:rPr sz="1600" b="0" i="0">
+              <a:rPr sz="2100" b="0" i="0">
                 <a:solidFill>
                   <a:srgbClr val="1F2A37"/>
                 </a:solidFill>
@@ -11740,7 +11278,7 @@
               </a:lnSpc>
             </a:pPr>
             <a:r>
-              <a:rPr sz="1600" b="0" i="0">
+              <a:rPr sz="2100" b="0" i="0">
                 <a:solidFill>
                   <a:srgbClr val="A0A7B1"/>
                 </a:solidFill>
@@ -11749,7 +11287,7 @@
               <a:t>2  </a:t>
             </a:r>
             <a:r>
-              <a:rPr sz="1600" b="0" i="0">
+              <a:rPr sz="2100" b="0" i="0">
                 <a:solidFill>
                   <a:srgbClr val="1F2A37"/>
                 </a:solidFill>
@@ -11765,7 +11303,7 @@
               </a:lnSpc>
             </a:pPr>
             <a:r>
-              <a:rPr sz="1600" b="0" i="0">
+              <a:rPr sz="2100" b="0" i="0">
                 <a:solidFill>
                   <a:srgbClr val="A0A7B1"/>
                 </a:solidFill>
@@ -11774,7 +11312,7 @@
               <a:t>3  </a:t>
             </a:r>
             <a:r>
-              <a:rPr sz="1600" b="0" i="0">
+              <a:rPr sz="2100" b="0" i="0">
                 <a:solidFill>
                   <a:srgbClr val="1F2A37"/>
                 </a:solidFill>
@@ -11783,7 +11321,7 @@
               <a:t>   </a:t>
             </a:r>
             <a:r>
-              <a:rPr sz="1600" b="0" i="0">
+              <a:rPr sz="2100" b="0" i="0">
                 <a:solidFill>
                   <a:srgbClr val="5F7F5F"/>
                 </a:solidFill>
@@ -11799,7 +11337,7 @@
               </a:lnSpc>
             </a:pPr>
             <a:r>
-              <a:rPr sz="1600" b="0" i="0">
+              <a:rPr sz="2100" b="0" i="0">
                 <a:solidFill>
                   <a:srgbClr val="A0A7B1"/>
                 </a:solidFill>
@@ -11808,7 +11346,7 @@
               <a:t>4  </a:t>
             </a:r>
             <a:r>
-              <a:rPr sz="1600" b="0" i="0">
+              <a:rPr sz="2100" b="0" i="0">
                 <a:solidFill>
                   <a:srgbClr val="1F2A37"/>
                 </a:solidFill>
@@ -11817,7 +11355,7 @@
               <a:t>   </a:t>
             </a:r>
             <a:r>
-              <a:rPr sz="1600" b="0" i="0">
+              <a:rPr sz="2100" b="0" i="0">
                 <a:solidFill>
                   <a:srgbClr val="5F7F5F"/>
                 </a:solidFill>
@@ -11833,7 +11371,7 @@
               </a:lnSpc>
             </a:pPr>
             <a:r>
-              <a:rPr sz="1600" b="0" i="0">
+              <a:rPr sz="2100" b="0" i="0">
                 <a:solidFill>
                   <a:srgbClr val="A0A7B1"/>
                 </a:solidFill>
@@ -11842,7 +11380,7 @@
               <a:t>5  </a:t>
             </a:r>
             <a:r>
-              <a:rPr sz="1600" b="0" i="0">
+              <a:rPr sz="2100" b="0" i="0">
                 <a:solidFill>
                   <a:srgbClr val="1F2A37"/>
                 </a:solidFill>
@@ -11858,7 +11396,7 @@
               </a:lnSpc>
             </a:pPr>
             <a:r>
-              <a:rPr sz="1600" b="0" i="0">
+              <a:rPr sz="2100" b="0" i="0">
                 <a:solidFill>
                   <a:srgbClr val="A0A7B1"/>
                 </a:solidFill>
@@ -11867,7 +11405,7 @@
               <a:t>6  </a:t>
             </a:r>
             <a:r>
-              <a:rPr sz="1600" b="1" i="0">
+              <a:rPr sz="2100" b="1" i="0">
                 <a:solidFill>
                   <a:srgbClr val="C00000"/>
                 </a:solidFill>
@@ -11876,7 +11414,7 @@
               <a:t>       </a:t>
             </a:r>
             <a:r>
-              <a:rPr sz="1600" b="0" i="0">
+              <a:rPr sz="2100" b="0" i="0">
                 <a:solidFill>
                   <a:srgbClr val="5F7F5F"/>
                 </a:solidFill>
@@ -11892,7 +11430,7 @@
               </a:lnSpc>
             </a:pPr>
             <a:r>
-              <a:rPr sz="1600" b="0" i="0">
+              <a:rPr sz="2100" b="0" i="0">
                 <a:solidFill>
                   <a:srgbClr val="A0A7B1"/>
                 </a:solidFill>
@@ -11901,7 +11439,7 @@
               <a:t>7  </a:t>
             </a:r>
             <a:r>
-              <a:rPr sz="1600" b="1" i="0">
+              <a:rPr sz="2100" b="1" i="0">
                 <a:solidFill>
                   <a:srgbClr val="C00000"/>
                 </a:solidFill>
@@ -11917,7 +11455,7 @@
               </a:lnSpc>
             </a:pPr>
             <a:r>
-              <a:rPr sz="1600" b="0" i="0">
+              <a:rPr sz="2100" b="0" i="0">
                 <a:solidFill>
                   <a:srgbClr val="A0A7B1"/>
                 </a:solidFill>
@@ -11926,7 +11464,7 @@
               <a:t>8  </a:t>
             </a:r>
             <a:r>
-              <a:rPr sz="1600" b="0" i="0">
+              <a:rPr sz="2100" b="0" i="0">
                 <a:solidFill>
                   <a:srgbClr val="1F2A37"/>
                 </a:solidFill>
@@ -11942,7 +11480,7 @@
               </a:lnSpc>
             </a:pPr>
             <a:r>
-              <a:rPr sz="1600" b="0" i="0">
+              <a:rPr sz="2100" b="0" i="0">
                 <a:solidFill>
                   <a:srgbClr val="A0A7B1"/>
                 </a:solidFill>
@@ -11951,7 +11489,7 @@
               <a:t>9  </a:t>
             </a:r>
             <a:r>
-              <a:rPr sz="1600" b="0" i="0">
+              <a:rPr sz="2100" b="0" i="0">
                 <a:solidFill>
                   <a:srgbClr val="1F2A37"/>
                 </a:solidFill>
@@ -11964,62 +11502,14 @@
       </p:sp>
       <p:sp>
         <p:nvSpPr>
-          <p:cNvPr id="7" name="Rounded Rectangle 6"/>
-          <p:cNvSpPr/>
+          <p:cNvPr id="7" name="TextBox 6"/>
+          <p:cNvSpPr txBox="1"/>
           <p:nvPr/>
         </p:nvSpPr>
         <p:spPr>
           <a:xfrm>
-            <a:off x="6751319" y="1325880"/>
-            <a:ext cx="4891735" cy="2651759"/>
-          </a:xfrm>
-          <a:prstGeom prst="roundRect">
-            <a:avLst>
-              <a:gd name="adj" fmla="val 8000"/>
-            </a:avLst>
-          </a:prstGeom>
-          <a:solidFill>
-            <a:srgbClr val="FFF4D6"/>
-          </a:solidFill>
-          <a:ln w="19050">
-            <a:solidFill>
-              <a:srgbClr val="B8860B"/>
-            </a:solidFill>
-          </a:ln>
-          <a:effectLst/>
-        </p:spPr>
-        <p:style>
-          <a:lnRef idx="1">
-            <a:schemeClr val="accent1"/>
-          </a:lnRef>
-          <a:fillRef idx="3">
-            <a:schemeClr val="accent1"/>
-          </a:fillRef>
-          <a:effectRef idx="2">
-            <a:schemeClr val="accent1"/>
-          </a:effectRef>
-          <a:fontRef idx="minor">
-            <a:schemeClr val="lt1"/>
-          </a:fontRef>
-        </p:style>
-        <p:txBody>
-          <a:bodyPr rtlCol="0" anchor="ctr"/>
-          <a:lstStyle/>
-          <a:p>
-            <a:pPr algn="ctr"/>
-          </a:p>
-        </p:txBody>
-      </p:sp>
-      <p:sp>
-        <p:nvSpPr>
-          <p:cNvPr id="8" name="TextBox 7"/>
-          <p:cNvSpPr txBox="1"/>
-          <p:nvPr/>
-        </p:nvSpPr>
-        <p:spPr>
-          <a:xfrm>
-            <a:off x="6934199" y="1463039"/>
-            <a:ext cx="4525975" cy="2377439"/>
+            <a:off x="548640" y="4951476"/>
+            <a:ext cx="7772400" cy="1403603"/>
           </a:xfrm>
           <a:prstGeom prst="rect">
             <a:avLst/>
@@ -12034,7 +11524,7 @@
           <a:p>
             <a:pPr>
               <a:spcAft>
-                <a:spcPts val="800"/>
+                <a:spcPts val="1000"/>
               </a:spcAft>
             </a:pPr>
             <a:r>
@@ -12044,10 +11534,28 @@
                 </a:solidFill>
                 <a:latin typeface="Calibri"/>
               </a:rPr>
-              <a:t>So gehst du vor</a:t>
-            </a:r>
-            <a:r>
-              <a:rPr sz="2000" b="0" i="0">
+              <a:t>▸ </a:t>
+            </a:r>
+            <a:r>
+              <a:rPr sz="2200" b="0" i="0">
+                <a:solidFill>
+                  <a:srgbClr val="1F2A37"/>
+                </a:solidFill>
+                <a:latin typeface="Calibri"/>
+              </a:rPr>
+              <a:t>Signatur in Abi-Notation steht </a:t>
+            </a:r>
+            <a:r>
+              <a:rPr sz="2200" b="1" i="0">
+                <a:solidFill>
+                  <a:srgbClr val="1F2A37"/>
+                </a:solidFill>
+                <a:latin typeface="Calibri"/>
+              </a:rPr>
+              <a:t>darüber</a:t>
+            </a:r>
+            <a:r>
+              <a:rPr sz="2200" b="0" i="0">
                 <a:solidFill>
                   <a:srgbClr val="1F2A37"/>
                 </a:solidFill>
@@ -12059,29 +11567,65 @@
           <a:p>
             <a:pPr>
               <a:spcAft>
-                <a:spcPts val="600"/>
+                <a:spcPts val="1000"/>
               </a:spcAft>
             </a:pPr>
             <a:r>
-              <a:rPr sz="2000" b="0" i="0">
-                <a:solidFill>
-                  <a:srgbClr val="1F2A37"/>
-                </a:solidFill>
-                <a:latin typeface="Calibri"/>
-              </a:rPr>
-              <a:t>Signatur in Abi-Notation steht </a:t>
-            </a:r>
-            <a:r>
-              <a:rPr sz="2000" b="1" i="0">
-                <a:solidFill>
-                  <a:srgbClr val="1F2A37"/>
-                </a:solidFill>
-                <a:latin typeface="Calibri"/>
-              </a:rPr>
-              <a:t>darüber</a:t>
-            </a:r>
-            <a:r>
-              <a:rPr sz="2000" b="0" i="0">
+              <a:rPr sz="2200" b="1" i="0">
+                <a:solidFill>
+                  <a:srgbClr val="B8860B"/>
+                </a:solidFill>
+                <a:latin typeface="Calibri"/>
+              </a:rPr>
+              <a:t>▸ </a:t>
+            </a:r>
+            <a:r>
+              <a:rPr sz="2100" b="0" i="0">
+                <a:solidFill>
+                  <a:srgbClr val="1F4E79"/>
+                </a:solidFill>
+                <a:latin typeface="Consolas"/>
+              </a:rPr>
+              <a:t>// TODO</a:t>
+            </a:r>
+            <a:r>
+              <a:rPr sz="2200" b="0" i="0">
+                <a:solidFill>
+                  <a:srgbClr val="1F2A37"/>
+                </a:solidFill>
+                <a:latin typeface="Calibri"/>
+              </a:rPr>
+              <a:t> und vorläufiges </a:t>
+            </a:r>
+            <a:r>
+              <a:rPr sz="2100" b="0" i="0">
+                <a:solidFill>
+                  <a:srgbClr val="1F4E79"/>
+                </a:solidFill>
+                <a:latin typeface="Consolas"/>
+              </a:rPr>
+              <a:t>return</a:t>
+            </a:r>
+            <a:r>
+              <a:rPr sz="2200" b="0" i="0">
+                <a:solidFill>
+                  <a:srgbClr val="1F2A37"/>
+                </a:solidFill>
+                <a:latin typeface="Calibri"/>
+              </a:rPr>
+              <a:t> </a:t>
+            </a:r>
+            <a:r>
+              <a:rPr sz="2200" b="1" i="0">
+                <a:solidFill>
+                  <a:srgbClr val="1F2A37"/>
+                </a:solidFill>
+                <a:latin typeface="Calibri"/>
+              </a:rPr>
+              <a:t>ersetzen</a:t>
+            </a:r>
+            <a:r>
+              <a:rPr sz="2200" b="0" i="0">
                 <a:solidFill>
                   <a:srgbClr val="1F2A37"/>
                 </a:solidFill>
@@ -12093,56 +11637,65 @@
           <a:p>
             <a:pPr>
               <a:spcAft>
-                <a:spcPts val="600"/>
+                <a:spcPts val="1000"/>
               </a:spcAft>
             </a:pPr>
             <a:r>
-              <a:rPr sz="1900" b="0" i="0">
-                <a:solidFill>
-                  <a:srgbClr val="1F4E79"/>
-                </a:solidFill>
-                <a:latin typeface="Consolas"/>
-              </a:rPr>
-              <a:t>// TODO</a:t>
-            </a:r>
-            <a:r>
-              <a:rPr sz="2000" b="0" i="0">
-                <a:solidFill>
-                  <a:srgbClr val="1F2A37"/>
-                </a:solidFill>
-                <a:latin typeface="Calibri"/>
-              </a:rPr>
-              <a:t> und vorläufiges </a:t>
-            </a:r>
-            <a:r>
-              <a:rPr sz="1900" b="0" i="0">
-                <a:solidFill>
-                  <a:srgbClr val="1F4E79"/>
-                </a:solidFill>
-                <a:latin typeface="Consolas"/>
-              </a:rPr>
-              <a:t>return</a:t>
-            </a:r>
-            <a:r>
-              <a:rPr sz="2000" b="0" i="0">
-                <a:solidFill>
-                  <a:srgbClr val="1F2A37"/>
-                </a:solidFill>
-                <a:latin typeface="Calibri"/>
-              </a:rPr>
-              <a:t> </a:t>
-            </a:r>
-            <a:r>
-              <a:rPr sz="2000" b="1" i="0">
-                <a:solidFill>
-                  <a:srgbClr val="1F2A37"/>
-                </a:solidFill>
-                <a:latin typeface="Calibri"/>
-              </a:rPr>
-              <a:t>ersetzen</a:t>
-            </a:r>
-            <a:r>
-              <a:rPr sz="2000" b="0" i="0">
+              <a:rPr sz="2200" b="1" i="0">
+                <a:solidFill>
+                  <a:srgbClr val="B8860B"/>
+                </a:solidFill>
+                <a:latin typeface="Calibri"/>
+              </a:rPr>
+              <a:t>▸ </a:t>
+            </a:r>
+            <a:r>
+              <a:rPr sz="2200" b="0" i="0">
+                <a:solidFill>
+                  <a:srgbClr val="1F2A37"/>
+                </a:solidFill>
+                <a:latin typeface="Calibri"/>
+              </a:rPr>
+              <a:t>Methodenkopf </a:t>
+            </a:r>
+            <a:r>
+              <a:rPr sz="2200" b="1" i="0">
+                <a:solidFill>
+                  <a:srgbClr val="1F2A37"/>
+                </a:solidFill>
+                <a:latin typeface="Calibri"/>
+              </a:rPr>
+              <a:t>nicht</a:t>
+            </a:r>
+            <a:r>
+              <a:rPr sz="2200" b="0" i="0">
+                <a:solidFill>
+                  <a:srgbClr val="1F2A37"/>
+                </a:solidFill>
+                <a:latin typeface="Calibri"/>
+              </a:rPr>
+              <a:t> ändern (</a:t>
+            </a:r>
+            <a:r>
+              <a:rPr sz="2200" b="1" i="0">
+                <a:solidFill>
+                  <a:srgbClr val="1F2A37"/>
+                </a:solidFill>
+                <a:latin typeface="Calibri"/>
+              </a:rPr>
+              <a:t>P3</a:t>
+            </a:r>
+            <a:r>
+              <a:rPr sz="2200" b="0" i="0">
+                <a:solidFill>
+                  <a:srgbClr val="1F2A37"/>
+                </a:solidFill>
+                <a:latin typeface="Calibri"/>
+              </a:rPr>
+              <a:t>)</a:t>
+            </a:r>
+            <a:r>
+              <a:rPr sz="2200" b="0" i="0">
                 <a:solidFill>
                   <a:srgbClr val="1F2A37"/>
                 </a:solidFill>
@@ -12151,72 +11704,11 @@
               <a:t/>
             </a:r>
           </a:p>
-          <a:p>
-            <a:pPr>
-              <a:spcAft>
-                <a:spcPts val="600"/>
-              </a:spcAft>
-            </a:pPr>
-            <a:r>
-              <a:rPr sz="2000" b="0" i="0">
-                <a:solidFill>
-                  <a:srgbClr val="1F2A37"/>
-                </a:solidFill>
-                <a:latin typeface="Calibri"/>
-              </a:rPr>
-              <a:t>Methodenkopf </a:t>
-            </a:r>
-            <a:r>
-              <a:rPr sz="2000" b="1" i="0">
-                <a:solidFill>
-                  <a:srgbClr val="1F2A37"/>
-                </a:solidFill>
-                <a:latin typeface="Calibri"/>
-              </a:rPr>
-              <a:t>nicht</a:t>
-            </a:r>
-            <a:r>
-              <a:rPr sz="2000" b="0" i="0">
-                <a:solidFill>
-                  <a:srgbClr val="1F2A37"/>
-                </a:solidFill>
-                <a:latin typeface="Calibri"/>
-              </a:rPr>
-              <a:t> ändern (</a:t>
-            </a:r>
-            <a:r>
-              <a:rPr sz="2000" b="1" i="0">
-                <a:solidFill>
-                  <a:srgbClr val="1F2A37"/>
-                </a:solidFill>
-                <a:latin typeface="Calibri"/>
-              </a:rPr>
-              <a:t>P3</a:t>
-            </a:r>
-            <a:r>
-              <a:rPr sz="2000" b="0" i="0">
-                <a:solidFill>
-                  <a:srgbClr val="1F2A37"/>
-                </a:solidFill>
-                <a:latin typeface="Calibri"/>
-              </a:rPr>
-              <a:t>)</a:t>
-            </a:r>
-            <a:r>
-              <a:rPr sz="2000" b="0" i="0">
-                <a:solidFill>
-                  <a:srgbClr val="1F2A37"/>
-                </a:solidFill>
-                <a:latin typeface="Calibri"/>
-              </a:rPr>
-              <a:t/>
-            </a:r>
-          </a:p>
-        </p:txBody>
-      </p:sp>
-      <p:sp>
-        <p:nvSpPr>
-          <p:cNvPr id="9" name="TextBox 8"/>
+        </p:txBody>
+      </p:sp>
+      <p:sp>
+        <p:nvSpPr>
+          <p:cNvPr id="8" name="TextBox 7"/>
           <p:cNvSpPr txBox="1"/>
           <p:nvPr/>
         </p:nvSpPr>
@@ -12397,7 +11889,7 @@
         <p:spPr>
           <a:xfrm>
             <a:off x="548640" y="1417320"/>
-            <a:ext cx="6050280" cy="2642616"/>
+            <a:ext cx="7772400" cy="1988819"/>
           </a:xfrm>
           <a:prstGeom prst="rect">
             <a:avLst/>
@@ -12443,7 +11935,7 @@
         <p:spPr>
           <a:xfrm>
             <a:off x="640080" y="1490472"/>
-            <a:ext cx="5867399" cy="2551176"/>
+            <a:ext cx="7589520" cy="1897379"/>
           </a:xfrm>
           <a:prstGeom prst="rect">
             <a:avLst/>
@@ -12462,7 +11954,7 @@
               </a:lnSpc>
             </a:pPr>
             <a:r>
-              <a:rPr sz="1600" b="0" i="0">
+              <a:rPr sz="2100" b="0" i="0">
                 <a:solidFill>
                   <a:srgbClr val="A0A7B1"/>
                 </a:solidFill>
@@ -12471,13 +11963,13 @@
               <a:t>1  </a:t>
             </a:r>
             <a:r>
-              <a:rPr sz="1600" b="0" i="0">
+              <a:rPr sz="2100" b="0" i="0">
                 <a:solidFill>
                   <a:srgbClr val="1F2A37"/>
                 </a:solidFill>
                 <a:latin typeface="Consolas"/>
               </a:rPr>
-              <a:t>class FackellagerTest {</a:t>
+              <a:t>@Test</a:t>
             </a:r>
           </a:p>
           <a:p>
@@ -12487,7 +11979,7 @@
               </a:lnSpc>
             </a:pPr>
             <a:r>
-              <a:rPr sz="1600" b="0" i="0">
+              <a:rPr sz="2100" b="0" i="0">
                 <a:solidFill>
                   <a:srgbClr val="A0A7B1"/>
                 </a:solidFill>
@@ -12496,13 +11988,13 @@
               <a:t>2  </a:t>
             </a:r>
             <a:r>
-              <a:rPr sz="1600" b="0" i="0">
+              <a:rPr sz="2100" b="0" i="0">
                 <a:solidFill>
                   <a:srgbClr val="1F2A37"/>
                 </a:solidFill>
                 <a:latin typeface="Consolas"/>
               </a:rPr>
-              <a:t/>
+              <a:t>public void angebrochen() {</a:t>
             </a:r>
           </a:p>
           <a:p>
@@ -12512,7 +12004,7 @@
               </a:lnSpc>
             </a:pPr>
             <a:r>
-              <a:rPr sz="1600" b="0" i="0">
+              <a:rPr sz="2100" b="0" i="0">
                 <a:solidFill>
                   <a:srgbClr val="A0A7B1"/>
                 </a:solidFill>
@@ -12521,13 +12013,13 @@
               <a:t>3  </a:t>
             </a:r>
             <a:r>
-              <a:rPr sz="1600" b="0" i="0">
-                <a:solidFill>
-                  <a:srgbClr val="1F2A37"/>
+              <a:rPr sz="2100" b="1" i="0">
+                <a:solidFill>
+                  <a:srgbClr val="C00000"/>
                 </a:solidFill>
                 <a:latin typeface="Consolas"/>
               </a:rPr>
-              <a:t>    @Test</a:t>
+              <a:t>    assertEquals(3, Fackellager.fackeln(7),</a:t>
             </a:r>
           </a:p>
           <a:p>
@@ -12537,7 +12029,7 @@
               </a:lnSpc>
             </a:pPr>
             <a:r>
-              <a:rPr sz="1600" b="0" i="0">
+              <a:rPr sz="2100" b="0" i="0">
                 <a:solidFill>
                   <a:srgbClr val="A0A7B1"/>
                 </a:solidFill>
@@ -12546,13 +12038,13 @@
               <a:t>4  </a:t>
             </a:r>
             <a:r>
-              <a:rPr sz="1600" b="0" i="0">
-                <a:solidFill>
-                  <a:srgbClr val="1F2A37"/>
+              <a:rPr sz="2100" b="1" i="0">
+                <a:solidFill>
+                  <a:srgbClr val="C00000"/>
                 </a:solidFill>
                 <a:latin typeface="Consolas"/>
               </a:rPr>
-              <a:t>    public void angebrochen() {</a:t>
+              <a:t>                 "7 Raeume: 3 Fackeln");</a:t>
             </a:r>
           </a:p>
           <a:p>
@@ -12562,7 +12054,7 @@
               </a:lnSpc>
             </a:pPr>
             <a:r>
-              <a:rPr sz="1600" b="0" i="0">
+              <a:rPr sz="2100" b="0" i="0">
                 <a:solidFill>
                   <a:srgbClr val="A0A7B1"/>
                 </a:solidFill>
@@ -12571,112 +12063,12 @@
               <a:t>5  </a:t>
             </a:r>
             <a:r>
-              <a:rPr sz="1600" b="1" i="0">
-                <a:solidFill>
-                  <a:srgbClr val="C00000"/>
+              <a:rPr sz="2100" b="0" i="0">
+                <a:solidFill>
+                  <a:srgbClr val="1F2A37"/>
                 </a:solidFill>
                 <a:latin typeface="Consolas"/>
               </a:rPr>
-              <a:t>        assertEquals(3,</a:t>
-            </a:r>
-          </a:p>
-          <a:p>
-            <a:pPr>
-              <a:lnSpc>
-                <a:spcPct val="100000"/>
-              </a:lnSpc>
-            </a:pPr>
-            <a:r>
-              <a:rPr sz="1600" b="0" i="0">
-                <a:solidFill>
-                  <a:srgbClr val="A0A7B1"/>
-                </a:solidFill>
-                <a:latin typeface="Consolas"/>
-              </a:rPr>
-              <a:t>6  </a:t>
-            </a:r>
-            <a:r>
-              <a:rPr sz="1600" b="1" i="0">
-                <a:solidFill>
-                  <a:srgbClr val="C00000"/>
-                </a:solidFill>
-                <a:latin typeface="Consolas"/>
-              </a:rPr>
-              <a:t>                     Fackellager.fackeln(7),</a:t>
-            </a:r>
-          </a:p>
-          <a:p>
-            <a:pPr>
-              <a:lnSpc>
-                <a:spcPct val="100000"/>
-              </a:lnSpc>
-            </a:pPr>
-            <a:r>
-              <a:rPr sz="1600" b="0" i="0">
-                <a:solidFill>
-                  <a:srgbClr val="A0A7B1"/>
-                </a:solidFill>
-                <a:latin typeface="Consolas"/>
-              </a:rPr>
-              <a:t>7  </a:t>
-            </a:r>
-            <a:r>
-              <a:rPr sz="1600" b="1" i="0">
-                <a:solidFill>
-                  <a:srgbClr val="C00000"/>
-                </a:solidFill>
-                <a:latin typeface="Consolas"/>
-              </a:rPr>
-              <a:t>                     "7 Raeume: 3 Fackeln");</a:t>
-            </a:r>
-          </a:p>
-          <a:p>
-            <a:pPr>
-              <a:lnSpc>
-                <a:spcPct val="100000"/>
-              </a:lnSpc>
-            </a:pPr>
-            <a:r>
-              <a:rPr sz="1600" b="0" i="0">
-                <a:solidFill>
-                  <a:srgbClr val="A0A7B1"/>
-                </a:solidFill>
-                <a:latin typeface="Consolas"/>
-              </a:rPr>
-              <a:t>8  </a:t>
-            </a:r>
-            <a:r>
-              <a:rPr sz="1600" b="0" i="0">
-                <a:solidFill>
-                  <a:srgbClr val="1F2A37"/>
-                </a:solidFill>
-                <a:latin typeface="Consolas"/>
-              </a:rPr>
-              <a:t>    }</a:t>
-            </a:r>
-          </a:p>
-          <a:p>
-            <a:pPr>
-              <a:lnSpc>
-                <a:spcPct val="100000"/>
-              </a:lnSpc>
-            </a:pPr>
-            <a:r>
-              <a:rPr sz="1600" b="0" i="0">
-                <a:solidFill>
-                  <a:srgbClr val="A0A7B1"/>
-                </a:solidFill>
-                <a:latin typeface="Consolas"/>
-              </a:rPr>
-              <a:t>9  </a:t>
-            </a:r>
-            <a:r>
-              <a:rPr sz="1600" b="0" i="0">
-                <a:solidFill>
-                  <a:srgbClr val="1F2A37"/>
-                </a:solidFill>
-                <a:latin typeface="Consolas"/>
-              </a:rPr>
               <a:t>}</a:t>
             </a:r>
           </a:p>
@@ -12684,62 +12076,14 @@
       </p:sp>
       <p:sp>
         <p:nvSpPr>
-          <p:cNvPr id="7" name="Rounded Rectangle 6"/>
-          <p:cNvSpPr/>
+          <p:cNvPr id="7" name="TextBox 6"/>
+          <p:cNvSpPr txBox="1"/>
           <p:nvPr/>
         </p:nvSpPr>
         <p:spPr>
           <a:xfrm>
-            <a:off x="6873239" y="1325880"/>
-            <a:ext cx="4769815" cy="2651759"/>
-          </a:xfrm>
-          <a:prstGeom prst="roundRect">
-            <a:avLst>
-              <a:gd name="adj" fmla="val 8000"/>
-            </a:avLst>
-          </a:prstGeom>
-          <a:solidFill>
-            <a:srgbClr val="DBE7F5"/>
-          </a:solidFill>
-          <a:ln w="19050">
-            <a:solidFill>
-              <a:srgbClr val="1F4E79"/>
-            </a:solidFill>
-          </a:ln>
-          <a:effectLst/>
-        </p:spPr>
-        <p:style>
-          <a:lnRef idx="1">
-            <a:schemeClr val="accent1"/>
-          </a:lnRef>
-          <a:fillRef idx="3">
-            <a:schemeClr val="accent1"/>
-          </a:fillRef>
-          <a:effectRef idx="2">
-            <a:schemeClr val="accent1"/>
-          </a:effectRef>
-          <a:fontRef idx="minor">
-            <a:schemeClr val="lt1"/>
-          </a:fontRef>
-        </p:style>
-        <p:txBody>
-          <a:bodyPr rtlCol="0" anchor="ctr"/>
-          <a:lstStyle/>
-          <a:p>
-            <a:pPr algn="ctr"/>
-          </a:p>
-        </p:txBody>
-      </p:sp>
-      <p:sp>
-        <p:nvSpPr>
-          <p:cNvPr id="8" name="TextBox 7"/>
-          <p:cNvSpPr txBox="1"/>
-          <p:nvPr/>
-        </p:nvSpPr>
-        <p:spPr>
-          <a:xfrm>
-            <a:off x="7056119" y="1463039"/>
-            <a:ext cx="4404055" cy="2377439"/>
+            <a:off x="548640" y="3543300"/>
+            <a:ext cx="7772400" cy="2811780"/>
           </a:xfrm>
           <a:prstGeom prst="rect">
             <a:avLst/>
@@ -12754,20 +12098,101 @@
           <a:p>
             <a:pPr>
               <a:spcAft>
-                <a:spcPts val="800"/>
+                <a:spcPts val="1000"/>
               </a:spcAft>
             </a:pPr>
             <a:r>
               <a:rPr sz="2200" b="1" i="0">
                 <a:solidFill>
+                  <a:srgbClr val="B8860B"/>
+                </a:solidFill>
+                <a:latin typeface="Calibri"/>
+              </a:rPr>
+              <a:t>▸ </a:t>
+            </a:r>
+            <a:r>
+              <a:rPr sz="2100" b="0" i="0">
+                <a:solidFill>
                   <a:srgbClr val="1F4E79"/>
                 </a:solidFill>
-                <a:latin typeface="Calibri"/>
-              </a:rPr>
-              <a:t>assertEquals(…)</a:t>
-            </a:r>
-            <a:r>
-              <a:rPr sz="2000" b="0" i="0">
+                <a:latin typeface="Consolas"/>
+              </a:rPr>
+              <a:t>assertEquals(</a:t>
+            </a:r>
+            <a:r>
+              <a:rPr sz="2200" b="0" i="0">
+                <a:solidFill>
+                  <a:srgbClr val="1F2A37"/>
+                </a:solidFill>
+                <a:latin typeface="Calibri"/>
+              </a:rPr>
+              <a:t> </a:t>
+            </a:r>
+            <a:r>
+              <a:rPr sz="2200" b="1" i="0">
+                <a:solidFill>
+                  <a:srgbClr val="1F2A37"/>
+                </a:solidFill>
+                <a:latin typeface="Calibri"/>
+              </a:rPr>
+              <a:t>erwartet</a:t>
+            </a:r>
+            <a:r>
+              <a:rPr sz="2200" b="0" i="0">
+                <a:solidFill>
+                  <a:srgbClr val="1F2A37"/>
+                </a:solidFill>
+                <a:latin typeface="Calibri"/>
+              </a:rPr>
+              <a:t>, </a:t>
+            </a:r>
+            <a:r>
+              <a:rPr sz="2200" b="1" i="0">
+                <a:solidFill>
+                  <a:srgbClr val="1F2A37"/>
+                </a:solidFill>
+                <a:latin typeface="Calibri"/>
+              </a:rPr>
+              <a:t>tatsächlich</a:t>
+            </a:r>
+            <a:r>
+              <a:rPr sz="2200" b="0" i="0">
+                <a:solidFill>
+                  <a:srgbClr val="1F2A37"/>
+                </a:solidFill>
+                <a:latin typeface="Calibri"/>
+              </a:rPr>
+              <a:t>, </a:t>
+            </a:r>
+            <a:r>
+              <a:rPr sz="2200" b="1" i="0">
+                <a:solidFill>
+                  <a:srgbClr val="1F2A37"/>
+                </a:solidFill>
+                <a:latin typeface="Calibri"/>
+              </a:rPr>
+              <a:t>Meldung</a:t>
+            </a:r>
+            <a:r>
+              <a:rPr sz="2200" b="0" i="0">
+                <a:solidFill>
+                  <a:srgbClr val="1F2A37"/>
+                </a:solidFill>
+                <a:latin typeface="Calibri"/>
+              </a:rPr>
+              <a:t> </a:t>
+            </a:r>
+            <a:r>
+              <a:rPr sz="2100" b="0" i="0">
+                <a:solidFill>
+                  <a:srgbClr val="1F4E79"/>
+                </a:solidFill>
+                <a:latin typeface="Consolas"/>
+              </a:rPr>
+              <a:t>)</a:t>
+            </a:r>
+            <a:r>
+              <a:rPr sz="2200" b="0" i="0">
                 <a:solidFill>
                   <a:srgbClr val="1F2A37"/>
                 </a:solidFill>
@@ -12779,47 +12204,47 @@
           <a:p>
             <a:pPr>
               <a:spcAft>
-                <a:spcPts val="600"/>
+                <a:spcPts val="1000"/>
               </a:spcAft>
             </a:pPr>
             <a:r>
-              <a:rPr sz="2000" b="0" i="0">
-                <a:solidFill>
-                  <a:srgbClr val="1F2A37"/>
-                </a:solidFill>
-                <a:latin typeface="Calibri"/>
-              </a:rPr>
-              <a:t>1. </a:t>
-            </a:r>
-            <a:r>
-              <a:rPr sz="2000" b="1" i="0">
-                <a:solidFill>
-                  <a:srgbClr val="1F2A37"/>
-                </a:solidFill>
-                <a:latin typeface="Calibri"/>
-              </a:rPr>
-              <a:t>erwartet</a:t>
-            </a:r>
-            <a:r>
-              <a:rPr sz="2000" b="0" i="0">
-                <a:solidFill>
-                  <a:srgbClr val="1F2A37"/>
-                </a:solidFill>
-                <a:latin typeface="Calibri"/>
-              </a:rPr>
-              <a:t>: </a:t>
-            </a:r>
-            <a:r>
-              <a:rPr sz="1900" b="0" i="0">
+              <a:rPr sz="2200" b="1" i="0">
+                <a:solidFill>
+                  <a:srgbClr val="B8860B"/>
+                </a:solidFill>
+                <a:latin typeface="Calibri"/>
+              </a:rPr>
+              <a:t>▸ </a:t>
+            </a:r>
+            <a:r>
+              <a:rPr sz="2100" b="0" i="0">
                 <a:solidFill>
                   <a:srgbClr val="1F4E79"/>
                 </a:solidFill>
                 <a:latin typeface="Consolas"/>
               </a:rPr>
-              <a:t>3</a:t>
-            </a:r>
-            <a:r>
-              <a:rPr sz="2000" b="0" i="0">
+              <a:t>@Test</a:t>
+            </a:r>
+            <a:r>
+              <a:rPr sz="2200" b="0" i="0">
+                <a:solidFill>
+                  <a:srgbClr val="1F2A37"/>
+                </a:solidFill>
+                <a:latin typeface="Calibri"/>
+              </a:rPr>
+              <a:t> macht die Methode zum Test – Klasse </a:t>
+            </a:r>
+            <a:r>
+              <a:rPr sz="2100" b="0" i="0">
+                <a:solidFill>
+                  <a:srgbClr val="1F4E79"/>
+                </a:solidFill>
+                <a:latin typeface="Consolas"/>
+              </a:rPr>
+              <a:t>FackellagerTest</a:t>
+            </a:r>
+            <a:r>
+              <a:rPr sz="2200" b="0" i="0">
                 <a:solidFill>
                   <a:srgbClr val="1F2A37"/>
                 </a:solidFill>
@@ -12828,140 +12253,11 @@
               <a:t/>
             </a:r>
           </a:p>
-          <a:p>
-            <a:pPr>
-              <a:spcAft>
-                <a:spcPts val="600"/>
-              </a:spcAft>
-            </a:pPr>
-            <a:r>
-              <a:rPr sz="2000" b="0" i="0">
-                <a:solidFill>
-                  <a:srgbClr val="1F2A37"/>
-                </a:solidFill>
-                <a:latin typeface="Calibri"/>
-              </a:rPr>
-              <a:t>2. </a:t>
-            </a:r>
-            <a:r>
-              <a:rPr sz="2000" b="1" i="0">
-                <a:solidFill>
-                  <a:srgbClr val="1F2A37"/>
-                </a:solidFill>
-                <a:latin typeface="Calibri"/>
-              </a:rPr>
-              <a:t>tatsächlich</a:t>
-            </a:r>
-            <a:r>
-              <a:rPr sz="2000" b="0" i="0">
-                <a:solidFill>
-                  <a:srgbClr val="1F2A37"/>
-                </a:solidFill>
-                <a:latin typeface="Calibri"/>
-              </a:rPr>
-              <a:t>: </a:t>
-            </a:r>
-            <a:r>
-              <a:rPr sz="1900" b="0" i="0">
-                <a:solidFill>
-                  <a:srgbClr val="1F4E79"/>
-                </a:solidFill>
-                <a:latin typeface="Consolas"/>
-              </a:rPr>
-              <a:t>Fackellager.fackeln(7)</a:t>
-            </a:r>
-            <a:r>
-              <a:rPr sz="2000" b="0" i="0">
-                <a:solidFill>
-                  <a:srgbClr val="1F2A37"/>
-                </a:solidFill>
-                <a:latin typeface="Calibri"/>
-              </a:rPr>
-              <a:t/>
-            </a:r>
-          </a:p>
-          <a:p>
-            <a:pPr>
-              <a:spcAft>
-                <a:spcPts val="600"/>
-              </a:spcAft>
-            </a:pPr>
-            <a:r>
-              <a:rPr sz="2000" b="0" i="0">
-                <a:solidFill>
-                  <a:srgbClr val="1F2A37"/>
-                </a:solidFill>
-                <a:latin typeface="Calibri"/>
-              </a:rPr>
-              <a:t>3. </a:t>
-            </a:r>
-            <a:r>
-              <a:rPr sz="2000" b="1" i="0">
-                <a:solidFill>
-                  <a:srgbClr val="1F2A37"/>
-                </a:solidFill>
-                <a:latin typeface="Calibri"/>
-              </a:rPr>
-              <a:t>Meldung</a:t>
-            </a:r>
-            <a:r>
-              <a:rPr sz="2000" b="0" i="0">
-                <a:solidFill>
-                  <a:srgbClr val="1F2A37"/>
-                </a:solidFill>
-                <a:latin typeface="Calibri"/>
-              </a:rPr>
-              <a:t> bei Rot</a:t>
-            </a:r>
-            <a:r>
-              <a:rPr sz="2000" b="0" i="0">
-                <a:solidFill>
-                  <a:srgbClr val="1F2A37"/>
-                </a:solidFill>
-                <a:latin typeface="Calibri"/>
-              </a:rPr>
-              <a:t/>
-            </a:r>
-          </a:p>
-          <a:p>
-            <a:pPr>
-              <a:spcAft>
-                <a:spcPts val="600"/>
-              </a:spcAft>
-            </a:pPr>
-            <a:r>
-              <a:rPr sz="1900" b="0" i="0">
-                <a:solidFill>
-                  <a:srgbClr val="1F4E79"/>
-                </a:solidFill>
-                <a:latin typeface="Consolas"/>
-              </a:rPr>
-              <a:t>@Test</a:t>
-            </a:r>
-            <a:r>
-              <a:rPr sz="2000" b="0" i="0">
-                <a:solidFill>
-                  <a:srgbClr val="1F2A37"/>
-                </a:solidFill>
-                <a:latin typeface="Calibri"/>
-              </a:rPr>
-              <a:t> macht die Methode zum Test</a:t>
-            </a:r>
-            <a:r>
-              <a:rPr sz="2000" b="0" i="0">
-                <a:solidFill>
-                  <a:srgbClr val="1F2A37"/>
-                </a:solidFill>
-                <a:latin typeface="Calibri"/>
-              </a:rPr>
-              <a:t/>
-            </a:r>
-          </a:p>
-        </p:txBody>
-      </p:sp>
-      <p:sp>
-        <p:nvSpPr>
-          <p:cNvPr id="9" name="TextBox 8"/>
+        </p:txBody>
+      </p:sp>
+      <p:sp>
+        <p:nvSpPr>
+          <p:cNvPr id="8" name="TextBox 7"/>
           <p:cNvSpPr txBox="1"/>
           <p:nvPr/>
         </p:nvSpPr>
@@ -13498,32 +12794,7 @@
                 </a:solidFill>
                 <a:latin typeface="Calibri"/>
               </a:rPr>
-              <a:t> grün –</a:t>
-            </a:r>
-            <a:r>
-              <a:rPr sz="2000" b="0" i="0">
-                <a:solidFill>
-                  <a:srgbClr val="1F2A37"/>
-                </a:solidFill>
-                <a:latin typeface="Calibri"/>
-              </a:rPr>
-              <a:t/>
-            </a:r>
-          </a:p>
-          <a:p>
-            <a:pPr>
-              <a:spcAft>
-                <a:spcPts val="600"/>
-              </a:spcAft>
-            </a:pPr>
-            <a:r>
-              <a:rPr sz="2000" b="0" i="0">
-                <a:solidFill>
-                  <a:srgbClr val="1F2A37"/>
-                </a:solidFill>
-                <a:latin typeface="Calibri"/>
-              </a:rPr>
-              <a:t>reiner Zufall, das zählt noch nicht.</a:t>
+              <a:t> schon grün – reiner Zufall, das zählt noch nicht.</a:t>
             </a:r>
             <a:r>
               <a:rPr sz="2000" b="0" i="0">
@@ -14557,7 +13828,7 @@
         <p:spPr>
           <a:xfrm>
             <a:off x="548640" y="1417320"/>
-            <a:ext cx="5440679" cy="1033271"/>
+            <a:ext cx="7772400" cy="1385316"/>
           </a:xfrm>
           <a:prstGeom prst="rect">
             <a:avLst/>
@@ -14603,7 +13874,7 @@
         <p:spPr>
           <a:xfrm>
             <a:off x="640080" y="1490472"/>
-            <a:ext cx="5257799" cy="941831"/>
+            <a:ext cx="7589520" cy="1293875"/>
           </a:xfrm>
           <a:prstGeom prst="rect">
             <a:avLst/>
@@ -14622,7 +13893,7 @@
               </a:lnSpc>
             </a:pPr>
             <a:r>
-              <a:rPr sz="1600" b="0" i="0">
+              <a:rPr sz="2300" b="0" i="0">
                 <a:solidFill>
                   <a:srgbClr val="A0A7B1"/>
                 </a:solidFill>
@@ -14631,7 +13902,7 @@
               <a:t>1  </a:t>
             </a:r>
             <a:r>
-              <a:rPr sz="1600" b="0" i="0">
+              <a:rPr sz="2300" b="0" i="0">
                 <a:solidFill>
                   <a:srgbClr val="1F2A37"/>
                 </a:solidFill>
@@ -14647,7 +13918,7 @@
               </a:lnSpc>
             </a:pPr>
             <a:r>
-              <a:rPr sz="1600" b="0" i="0">
+              <a:rPr sz="2300" b="0" i="0">
                 <a:solidFill>
                   <a:srgbClr val="A0A7B1"/>
                 </a:solidFill>
@@ -14656,7 +13927,7 @@
               <a:t>2  </a:t>
             </a:r>
             <a:r>
-              <a:rPr sz="1600" b="1" i="0">
+              <a:rPr sz="2300" b="1" i="0">
                 <a:solidFill>
                   <a:srgbClr val="C00000"/>
                 </a:solidFill>
@@ -14672,7 +13943,7 @@
               </a:lnSpc>
             </a:pPr>
             <a:r>
-              <a:rPr sz="1600" b="0" i="0">
+              <a:rPr sz="2300" b="0" i="0">
                 <a:solidFill>
                   <a:srgbClr val="A0A7B1"/>
                 </a:solidFill>
@@ -14681,7 +13952,7 @@
               <a:t>3  </a:t>
             </a:r>
             <a:r>
-              <a:rPr sz="1600" b="0" i="0">
+              <a:rPr sz="2300" b="0" i="0">
                 <a:solidFill>
                   <a:srgbClr val="1F2A37"/>
                 </a:solidFill>
@@ -14700,8 +13971,8 @@
         </p:nvSpPr>
         <p:spPr>
           <a:xfrm>
-            <a:off x="548640" y="2587752"/>
-            <a:ext cx="5440679" cy="3767328"/>
+            <a:off x="548640" y="2939796"/>
+            <a:ext cx="7772400" cy="3415284"/>
           </a:xfrm>
           <a:prstGeom prst="rect">
             <a:avLst/>
@@ -14720,7 +13991,7 @@
               </a:spcAft>
             </a:pPr>
             <a:r>
-              <a:rPr sz="2000" b="1" i="0">
+              <a:rPr sz="2200" b="1" i="0">
                 <a:solidFill>
                   <a:srgbClr val="B8860B"/>
                 </a:solidFill>
@@ -14729,61 +14000,25 @@
               <a:t>▸ </a:t>
             </a:r>
             <a:r>
-              <a:rPr sz="1900" b="0" i="0">
-                <a:solidFill>
-                  <a:srgbClr val="1F4E79"/>
-                </a:solidFill>
-                <a:latin typeface="Consolas"/>
-              </a:rPr>
-              <a:t>(7 + 2) / 3</a:t>
-            </a:r>
-            <a:r>
-              <a:rPr sz="2000" b="0" i="0">
-                <a:solidFill>
-                  <a:srgbClr val="1F2A37"/>
-                </a:solidFill>
-                <a:latin typeface="Calibri"/>
-              </a:rPr>
-              <a:t> = 3 · </a:t>
-            </a:r>
-            <a:r>
-              <a:rPr sz="1900" b="0" i="0">
-                <a:solidFill>
-                  <a:srgbClr val="1F4E79"/>
-                </a:solidFill>
-                <a:latin typeface="Consolas"/>
-              </a:rPr>
-              <a:t>(3 + 2) / 3</a:t>
-            </a:r>
-            <a:r>
-              <a:rPr sz="2000" b="0" i="0">
-                <a:solidFill>
-                  <a:srgbClr val="1F2A37"/>
-                </a:solidFill>
-                <a:latin typeface="Calibri"/>
-              </a:rPr>
-              <a:t> = 1 · </a:t>
-            </a:r>
-            <a:r>
-              <a:rPr sz="1900" b="0" i="0">
-                <a:solidFill>
-                  <a:srgbClr val="1F4E79"/>
-                </a:solidFill>
-                <a:latin typeface="Consolas"/>
-              </a:rPr>
-              <a:t>(0 + 2) / 3</a:t>
-            </a:r>
-            <a:r>
-              <a:rPr sz="2000" b="0" i="0">
-                <a:solidFill>
-                  <a:srgbClr val="1F2A37"/>
-                </a:solidFill>
-                <a:latin typeface="Calibri"/>
-              </a:rPr>
-              <a:t> = 0</a:t>
-            </a:r>
-            <a:r>
-              <a:rPr sz="2000" b="0" i="0">
+              <a:rPr sz="2200" b="0" i="0">
+                <a:solidFill>
+                  <a:srgbClr val="1F2A37"/>
+                </a:solidFill>
+                <a:latin typeface="Calibri"/>
+              </a:rPr>
+              <a:t>+ 2 vor dem Teilen rundet </a:t>
+            </a:r>
+            <a:r>
+              <a:rPr sz="2200" b="1" i="0">
+                <a:solidFill>
+                  <a:srgbClr val="1F2A37"/>
+                </a:solidFill>
+                <a:latin typeface="Calibri"/>
+              </a:rPr>
+              <a:t>auf</a:t>
+            </a:r>
+            <a:r>
+              <a:rPr sz="2200" b="0" i="0">
                 <a:solidFill>
                   <a:srgbClr val="1F2A37"/>
                 </a:solidFill>
@@ -14799,7 +14034,7 @@
               </a:spcAft>
             </a:pPr>
             <a:r>
-              <a:rPr sz="2000" b="1" i="0">
+              <a:rPr sz="2200" b="1" i="0">
                 <a:solidFill>
                   <a:srgbClr val="B8860B"/>
                 </a:solidFill>
@@ -14808,25 +14043,61 @@
               <a:t>▸ </a:t>
             </a:r>
             <a:r>
-              <a:rPr sz="2000" b="0" i="0">
-                <a:solidFill>
-                  <a:srgbClr val="1F2A37"/>
-                </a:solidFill>
-                <a:latin typeface="Calibri"/>
-              </a:rPr>
-              <a:t>Testrunner: </a:t>
-            </a:r>
-            <a:r>
-              <a:rPr sz="2000" b="1" i="0">
-                <a:solidFill>
-                  <a:srgbClr val="1F2A37"/>
-                </a:solidFill>
-                <a:latin typeface="Calibri"/>
-              </a:rPr>
-              <a:t>3 von 3 grün</a:t>
-            </a:r>
-            <a:r>
-              <a:rPr sz="2000" b="0" i="0">
+              <a:rPr sz="2100" b="0" i="0">
+                <a:solidFill>
+                  <a:srgbClr val="1F4E79"/>
+                </a:solidFill>
+                <a:latin typeface="Consolas"/>
+              </a:rPr>
+              <a:t>(7 + 2) / 3</a:t>
+            </a:r>
+            <a:r>
+              <a:rPr sz="2200" b="0" i="0">
+                <a:solidFill>
+                  <a:srgbClr val="1F2A37"/>
+                </a:solidFill>
+                <a:latin typeface="Calibri"/>
+              </a:rPr>
+              <a:t> = 3 · </a:t>
+            </a:r>
+            <a:r>
+              <a:rPr sz="2100" b="0" i="0">
+                <a:solidFill>
+                  <a:srgbClr val="1F4E79"/>
+                </a:solidFill>
+                <a:latin typeface="Consolas"/>
+              </a:rPr>
+              <a:t>(3 + 2) / 3</a:t>
+            </a:r>
+            <a:r>
+              <a:rPr sz="2200" b="0" i="0">
+                <a:solidFill>
+                  <a:srgbClr val="1F2A37"/>
+                </a:solidFill>
+                <a:latin typeface="Calibri"/>
+              </a:rPr>
+              <a:t> = 1 · </a:t>
+            </a:r>
+            <a:r>
+              <a:rPr sz="2100" b="0" i="0">
+                <a:solidFill>
+                  <a:srgbClr val="1F4E79"/>
+                </a:solidFill>
+                <a:latin typeface="Consolas"/>
+              </a:rPr>
+              <a:t>(0 + 2) / 3</a:t>
+            </a:r>
+            <a:r>
+              <a:rPr sz="2200" b="0" i="0">
+                <a:solidFill>
+                  <a:srgbClr val="1F2A37"/>
+                </a:solidFill>
+                <a:latin typeface="Calibri"/>
+              </a:rPr>
+              <a:t> = 0</a:t>
+            </a:r>
+            <a:r>
+              <a:rPr sz="2200" b="0" i="0">
                 <a:solidFill>
                   <a:srgbClr val="1F2A37"/>
                 </a:solidFill>
@@ -14835,94 +14106,41 @@
               <a:t/>
             </a:r>
           </a:p>
-        </p:txBody>
-      </p:sp>
-      <p:sp>
-        <p:nvSpPr>
-          <p:cNvPr id="8" name="Rounded Rectangle 7"/>
-          <p:cNvSpPr/>
-          <p:nvPr/>
-        </p:nvSpPr>
-        <p:spPr>
-          <a:xfrm>
-            <a:off x="6263639" y="1325880"/>
-            <a:ext cx="5379415" cy="2651759"/>
-          </a:xfrm>
-          <a:prstGeom prst="roundRect">
-            <a:avLst>
-              <a:gd name="adj" fmla="val 8000"/>
-            </a:avLst>
-          </a:prstGeom>
-          <a:solidFill>
-            <a:srgbClr val="E2EFDA"/>
-          </a:solidFill>
-          <a:ln w="19050">
-            <a:solidFill>
-              <a:srgbClr val="548235"/>
-            </a:solidFill>
-          </a:ln>
-          <a:effectLst/>
-        </p:spPr>
-        <p:style>
-          <a:lnRef idx="1">
-            <a:schemeClr val="accent1"/>
-          </a:lnRef>
-          <a:fillRef idx="3">
-            <a:schemeClr val="accent1"/>
-          </a:fillRef>
-          <a:effectRef idx="2">
-            <a:schemeClr val="accent1"/>
-          </a:effectRef>
-          <a:fontRef idx="minor">
-            <a:schemeClr val="lt1"/>
-          </a:fontRef>
-        </p:style>
-        <p:txBody>
-          <a:bodyPr rtlCol="0" anchor="ctr"/>
-          <a:lstStyle/>
-          <a:p>
-            <a:pPr algn="ctr"/>
-          </a:p>
-        </p:txBody>
-      </p:sp>
-      <p:sp>
-        <p:nvSpPr>
-          <p:cNvPr id="9" name="TextBox 8"/>
-          <p:cNvSpPr txBox="1"/>
-          <p:nvPr/>
-        </p:nvSpPr>
-        <p:spPr>
-          <a:xfrm>
-            <a:off x="6446519" y="1463039"/>
-            <a:ext cx="5013655" cy="2377439"/>
-          </a:xfrm>
-          <a:prstGeom prst="rect">
-            <a:avLst/>
-          </a:prstGeom>
-          <a:noFill/>
-        </p:spPr>
-        <p:txBody>
-          <a:bodyPr wrap="square" anchor="t" lIns="45720" rIns="45720">
-            <a:spAutoFit/>
-          </a:bodyPr>
-          <a:lstStyle/>
           <a:p>
             <a:pPr>
               <a:spcAft>
-                <a:spcPts val="800"/>
+                <a:spcPts val="1000"/>
               </a:spcAft>
             </a:pPr>
             <a:r>
               <a:rPr sz="2200" b="1" i="0">
                 <a:solidFill>
-                  <a:srgbClr val="548235"/>
-                </a:solidFill>
-                <a:latin typeface="Calibri"/>
-              </a:rPr>
-              <a:t>Der Trick</a:t>
-            </a:r>
-            <a:r>
-              <a:rPr sz="2000" b="0" i="0">
+                  <a:srgbClr val="B8860B"/>
+                </a:solidFill>
+                <a:latin typeface="Calibri"/>
+              </a:rPr>
+              <a:t>▸ </a:t>
+            </a:r>
+            <a:r>
+              <a:rPr sz="2200" b="0" i="0">
+                <a:solidFill>
+                  <a:srgbClr val="1F2A37"/>
+                </a:solidFill>
+                <a:latin typeface="Calibri"/>
+              </a:rPr>
+              <a:t>Alle Tests neu starten: </a:t>
+            </a:r>
+            <a:r>
+              <a:rPr sz="2200" b="1" i="0">
+                <a:solidFill>
+                  <a:srgbClr val="1F2A37"/>
+                </a:solidFill>
+                <a:latin typeface="Calibri"/>
+              </a:rPr>
+              <a:t>3 von 3 grün</a:t>
+            </a:r>
+            <a:r>
+              <a:rPr sz="2200" b="0" i="0">
                 <a:solidFill>
                   <a:srgbClr val="1F2A37"/>
                 </a:solidFill>
@@ -14931,88 +14149,11 @@
               <a:t/>
             </a:r>
           </a:p>
-          <a:p>
-            <a:pPr>
-              <a:spcAft>
-                <a:spcPts val="600"/>
-              </a:spcAft>
-            </a:pPr>
-            <a:r>
-              <a:rPr sz="2000" b="0" i="0">
-                <a:solidFill>
-                  <a:srgbClr val="1F2A37"/>
-                </a:solidFill>
-                <a:latin typeface="Calibri"/>
-              </a:rPr>
-              <a:t>+ 2 vor dem Teilen rundet </a:t>
-            </a:r>
-            <a:r>
-              <a:rPr sz="2000" b="1" i="0">
-                <a:solidFill>
-                  <a:srgbClr val="1F2A37"/>
-                </a:solidFill>
-                <a:latin typeface="Calibri"/>
-              </a:rPr>
-              <a:t>auf</a:t>
-            </a:r>
-            <a:r>
-              <a:rPr sz="2000" b="0" i="0">
-                <a:solidFill>
-                  <a:srgbClr val="1F2A37"/>
-                </a:solidFill>
-                <a:latin typeface="Calibri"/>
-              </a:rPr>
-              <a:t/>
-            </a:r>
-          </a:p>
-          <a:p>
-            <a:pPr>
-              <a:spcAft>
-                <a:spcPts val="600"/>
-              </a:spcAft>
-            </a:pPr>
-            <a:r>
-              <a:rPr sz="2000" b="0" i="0">
-                <a:solidFill>
-                  <a:srgbClr val="1F2A37"/>
-                </a:solidFill>
-                <a:latin typeface="Calibri"/>
-              </a:rPr>
-              <a:t>Danach </a:t>
-            </a:r>
-            <a:r>
-              <a:rPr sz="2000" b="1" i="0">
-                <a:solidFill>
-                  <a:srgbClr val="1F2A37"/>
-                </a:solidFill>
-                <a:latin typeface="Calibri"/>
-              </a:rPr>
-              <a:t>alle</a:t>
-            </a:r>
-            <a:r>
-              <a:rPr sz="2000" b="0" i="0">
-                <a:solidFill>
-                  <a:srgbClr val="1F2A37"/>
-                </a:solidFill>
-                <a:latin typeface="Calibri"/>
-              </a:rPr>
-              <a:t> Tests noch einmal starten</a:t>
-            </a:r>
-            <a:r>
-              <a:rPr sz="2000" b="0" i="0">
-                <a:solidFill>
-                  <a:srgbClr val="1F2A37"/>
-                </a:solidFill>
-                <a:latin typeface="Calibri"/>
-              </a:rPr>
-              <a:t/>
-            </a:r>
-          </a:p>
-        </p:txBody>
-      </p:sp>
-      <p:sp>
-        <p:nvSpPr>
-          <p:cNvPr id="10" name="TextBox 9"/>
+        </p:txBody>
+      </p:sp>
+      <p:sp>
+        <p:nvSpPr>
+          <p:cNvPr id="8" name="TextBox 7"/>
           <p:cNvSpPr txBox="1"/>
           <p:nvPr/>
         </p:nvSpPr>

</xml_diff>